<commit_message>
Deck: add plain-English explanation slide for the PageSpeed numbers
Companion slide after the PageSpeed results that translates each measure for a
non-technical audience (score = exam mark; LCP = main image appears; TBT = page
responds to taps; Speed Index = looks finished; FCP = you see something), with
the old->new change and a bottom-line takeaway on rankings + enquiries.

Co-Authored-By: Claude Opus 4.8 (1M context) <noreply@anthropic.com>
Claude-Session: https://claude.ai/code/session_01JBb5MKmF3Fs7o1qCwzd3N5
</commit_message>
<xml_diff>
--- a/docs/Ricoman-New-Website.pptx
+++ b/docs/Ricoman-New-Website.pptx
@@ -18,6 +18,7 @@
     <p:sldId id="266" r:id="rId17"/>
     <p:sldId id="267" r:id="rId18"/>
     <p:sldId id="268" r:id="rId19"/>
+    <p:sldId id="269" r:id="rId20"/>
   </p:sldIdLst>
   <p:sldSz cx="12191695" cy="6858000" type="screen4x3"/>
   <p:notesSz cx="6858000" cy="9144000"/>
@@ -5666,7 +5667,7 @@
                 </a:solidFill>
                 <a:latin typeface="Calibri"/>
               </a:rPr>
-              <a:t>ROADMAP</a:t>
+              <a:t>MEASURED RESULTS</a:t>
             </a:r>
           </a:p>
           <a:p>
@@ -5685,7 +5686,7 @@
                 </a:solidFill>
                 <a:latin typeface="Calibri"/>
               </a:rPr>
-              <a:t>Where we are</a:t>
+              <a:t>What those PageSpeed numbers mean</a:t>
             </a:r>
           </a:p>
         </p:txBody>
@@ -5736,14 +5737,100 @@
       </p:sp>
       <p:sp>
         <p:nvSpPr>
-          <p:cNvPr id="6" name="Rectangle 5"/>
+          <p:cNvPr id="6" name="TextBox 5"/>
+          <p:cNvSpPr txBox="1"/>
+          <p:nvPr/>
+        </p:nvSpPr>
+        <p:spPr>
+          <a:xfrm>
+            <a:off x="548640" y="1371600"/>
+            <a:ext cx="11155680" cy="457200"/>
+          </a:xfrm>
+          <a:prstGeom prst="rect">
+            <a:avLst/>
+          </a:prstGeom>
+          <a:noFill/>
+        </p:spPr>
+        <p:txBody>
+          <a:bodyPr wrap="square" anchor="t">
+            <a:spAutoFit/>
+          </a:bodyPr>
+          <a:lstStyle/>
+          <a:p>
+            <a:pPr algn="l">
+              <a:spcBef>
+                <a:spcPts val="0"/>
+              </a:spcBef>
+              <a:spcAft>
+                <a:spcPts val="0"/>
+              </a:spcAft>
+            </a:pPr>
+            <a:r>
+              <a:rPr sz="1300" b="0">
+                <a:solidFill>
+                  <a:srgbClr val="5B626D"/>
+                </a:solidFill>
+                <a:latin typeface="Calibri"/>
+              </a:rPr>
+              <a:t>In plain English — what each measure is, and what changed.</a:t>
+            </a:r>
+          </a:p>
+        </p:txBody>
+      </p:sp>
+      <p:sp>
+        <p:nvSpPr>
+          <p:cNvPr id="7" name="Rectangle 6"/>
           <p:cNvSpPr/>
           <p:nvPr/>
         </p:nvSpPr>
         <p:spPr>
           <a:xfrm>
-            <a:off x="548640" y="1645920"/>
-            <a:ext cx="685800" cy="777240"/>
+            <a:off x="548640" y="1874519"/>
+            <a:ext cx="11064240" cy="713232"/>
+          </a:xfrm>
+          <a:prstGeom prst="rect">
+            <a:avLst/>
+          </a:prstGeom>
+          <a:solidFill>
+            <a:srgbClr val="F4F6F8"/>
+          </a:solidFill>
+          <a:ln>
+            <a:noFill/>
+          </a:ln>
+          <a:effectLst/>
+        </p:spPr>
+        <p:style>
+          <a:lnRef idx="1">
+            <a:schemeClr val="accent1"/>
+          </a:lnRef>
+          <a:fillRef idx="3">
+            <a:schemeClr val="accent1"/>
+          </a:fillRef>
+          <a:effectRef idx="2">
+            <a:schemeClr val="accent1"/>
+          </a:effectRef>
+          <a:fontRef idx="minor">
+            <a:schemeClr val="lt1"/>
+          </a:fontRef>
+        </p:style>
+        <p:txBody>
+          <a:bodyPr rtlCol="0" anchor="ctr"/>
+          <a:lstStyle/>
+          <a:p>
+            <a:pPr algn="ctr"/>
+          </a:p>
+        </p:txBody>
+      </p:sp>
+      <p:sp>
+        <p:nvSpPr>
+          <p:cNvPr id="8" name="Rectangle 7"/>
+          <p:cNvSpPr/>
+          <p:nvPr/>
+        </p:nvSpPr>
+        <p:spPr>
+          <a:xfrm>
+            <a:off x="548640" y="1874519"/>
+            <a:ext cx="91440" cy="713232"/>
           </a:xfrm>
           <a:prstGeom prst="rect">
             <a:avLst/>
@@ -5780,14 +5867,14 @@
       </p:sp>
       <p:sp>
         <p:nvSpPr>
-          <p:cNvPr id="7" name="TextBox 6"/>
+          <p:cNvPr id="9" name="TextBox 8"/>
           <p:cNvSpPr txBox="1"/>
           <p:nvPr/>
         </p:nvSpPr>
         <p:spPr>
           <a:xfrm>
-            <a:off x="548640" y="1645920"/>
-            <a:ext cx="685800" cy="777240"/>
+            <a:off x="777240" y="1874519"/>
+            <a:ext cx="2743200" cy="713232"/>
           </a:xfrm>
           <a:prstGeom prst="rect">
             <a:avLst/>
@@ -5800,36 +5887,97 @@
           </a:bodyPr>
           <a:lstStyle/>
           <a:p>
-            <a:pPr algn="ctr">
-              <a:spcBef>
-                <a:spcPts val="0"/>
-              </a:spcBef>
-              <a:spcAft>
-                <a:spcPts val="0"/>
-              </a:spcAft>
-            </a:pPr>
-            <a:r>
-              <a:rPr sz="2600" b="1">
-                <a:solidFill>
-                  <a:srgbClr val="FFFFFF"/>
-                </a:solidFill>
-                <a:latin typeface="Calibri"/>
-              </a:rPr>
-              <a:t>1</a:t>
-            </a:r>
-          </a:p>
-        </p:txBody>
-      </p:sp>
-      <p:sp>
-        <p:nvSpPr>
-          <p:cNvPr id="8" name="Rectangle 7"/>
+            <a:pPr algn="l">
+              <a:spcBef>
+                <a:spcPts val="0"/>
+              </a:spcBef>
+              <a:spcAft>
+                <a:spcPts val="100"/>
+              </a:spcAft>
+            </a:pPr>
+            <a:r>
+              <a:rPr sz="1300" b="1">
+                <a:solidFill>
+                  <a:srgbClr val="0B0B0C"/>
+                </a:solidFill>
+                <a:latin typeface="Calibri"/>
+              </a:rPr>
+              <a:t>Score /100</a:t>
+            </a:r>
+          </a:p>
+          <a:p>
+            <a:pPr algn="l">
+              <a:spcBef>
+                <a:spcPts val="0"/>
+              </a:spcBef>
+              <a:spcAft>
+                <a:spcPts val="0"/>
+              </a:spcAft>
+            </a:pPr>
+            <a:r>
+              <a:rPr sz="1200" b="1">
+                <a:solidFill>
+                  <a:srgbClr val="1A7F37"/>
+                </a:solidFill>
+                <a:latin typeface="Calibri"/>
+              </a:rPr>
+              <a:t>32 → 93 (mobile)</a:t>
+            </a:r>
+          </a:p>
+        </p:txBody>
+      </p:sp>
+      <p:sp>
+        <p:nvSpPr>
+          <p:cNvPr id="10" name="TextBox 9"/>
+          <p:cNvSpPr txBox="1"/>
+          <p:nvPr/>
+        </p:nvSpPr>
+        <p:spPr>
+          <a:xfrm>
+            <a:off x="3657600" y="1874519"/>
+            <a:ext cx="7772400" cy="713232"/>
+          </a:xfrm>
+          <a:prstGeom prst="rect">
+            <a:avLst/>
+          </a:prstGeom>
+          <a:noFill/>
+        </p:spPr>
+        <p:txBody>
+          <a:bodyPr wrap="square" anchor="ctr">
+            <a:spAutoFit/>
+          </a:bodyPr>
+          <a:lstStyle/>
+          <a:p>
+            <a:pPr algn="l">
+              <a:spcBef>
+                <a:spcPts val="0"/>
+              </a:spcBef>
+              <a:spcAft>
+                <a:spcPts val="0"/>
+              </a:spcAft>
+            </a:pPr>
+            <a:r>
+              <a:rPr sz="1250" b="0">
+                <a:solidFill>
+                  <a:srgbClr val="16335C"/>
+                </a:solidFill>
+                <a:latin typeface="Calibri"/>
+              </a:rPr>
+              <a:t>A speed exam mark. 32 is a fail; 93 is a top grade. Google uses this mark to help decide search rankings.</a:t>
+            </a:r>
+          </a:p>
+        </p:txBody>
+      </p:sp>
+      <p:sp>
+        <p:nvSpPr>
+          <p:cNvPr id="11" name="Rectangle 10"/>
           <p:cNvSpPr/>
           <p:nvPr/>
         </p:nvSpPr>
         <p:spPr>
           <a:xfrm>
-            <a:off x="1325880" y="1645920"/>
-            <a:ext cx="10287000" cy="777240"/>
+            <a:off x="548640" y="2651759"/>
+            <a:ext cx="11064240" cy="713232"/>
           </a:xfrm>
           <a:prstGeom prst="rect">
             <a:avLst/>
@@ -5866,75 +6014,14 @@
       </p:sp>
       <p:sp>
         <p:nvSpPr>
-          <p:cNvPr id="9" name="TextBox 8"/>
-          <p:cNvSpPr txBox="1"/>
-          <p:nvPr/>
-        </p:nvSpPr>
-        <p:spPr>
-          <a:xfrm>
-            <a:off x="1554480" y="1719072"/>
-            <a:ext cx="9875520" cy="685800"/>
-          </a:xfrm>
-          <a:prstGeom prst="rect">
-            <a:avLst/>
-          </a:prstGeom>
-          <a:noFill/>
-        </p:spPr>
-        <p:txBody>
-          <a:bodyPr wrap="square" anchor="ctr">
-            <a:spAutoFit/>
-          </a:bodyPr>
-          <a:lstStyle/>
-          <a:p>
-            <a:pPr algn="l">
-              <a:spcBef>
-                <a:spcPts val="0"/>
-              </a:spcBef>
-              <a:spcAft>
-                <a:spcPts val="200"/>
-              </a:spcAft>
-            </a:pPr>
-            <a:r>
-              <a:rPr sz="1600" b="1">
-                <a:solidFill>
-                  <a:srgbClr val="0B0B0C"/>
-                </a:solidFill>
-                <a:latin typeface="Calibri"/>
-              </a:rPr>
-              <a:t>Recreate ricoman.com exactly on the new platform</a:t>
-            </a:r>
-          </a:p>
-          <a:p>
-            <a:pPr algn="l">
-              <a:spcBef>
-                <a:spcPts val="0"/>
-              </a:spcBef>
-              <a:spcAft>
-                <a:spcPts val="0"/>
-              </a:spcAft>
-            </a:pPr>
-            <a:r>
-              <a:rPr sz="1250" b="0">
-                <a:solidFill>
-                  <a:srgbClr val="5B626D"/>
-                </a:solidFill>
-                <a:latin typeface="Calibri"/>
-              </a:rPr>
-              <a:t>In progress — confirming each page matches live</a:t>
-            </a:r>
-          </a:p>
-        </p:txBody>
-      </p:sp>
-      <p:sp>
-        <p:nvSpPr>
-          <p:cNvPr id="10" name="Rectangle 9"/>
+          <p:cNvPr id="12" name="Rectangle 11"/>
           <p:cNvSpPr/>
           <p:nvPr/>
         </p:nvSpPr>
         <p:spPr>
           <a:xfrm>
-            <a:off x="548640" y="2560320"/>
-            <a:ext cx="685800" cy="777240"/>
+            <a:off x="548640" y="2651759"/>
+            <a:ext cx="91440" cy="713232"/>
           </a:xfrm>
           <a:prstGeom prst="rect">
             <a:avLst/>
@@ -5971,14 +6058,14 @@
       </p:sp>
       <p:sp>
         <p:nvSpPr>
-          <p:cNvPr id="11" name="TextBox 10"/>
+          <p:cNvPr id="13" name="TextBox 12"/>
           <p:cNvSpPr txBox="1"/>
           <p:nvPr/>
         </p:nvSpPr>
         <p:spPr>
           <a:xfrm>
-            <a:off x="548640" y="2560320"/>
-            <a:ext cx="685800" cy="777240"/>
+            <a:off x="777240" y="2651759"/>
+            <a:ext cx="2743200" cy="713232"/>
           </a:xfrm>
           <a:prstGeom prst="rect">
             <a:avLst/>
@@ -5991,36 +6078,97 @@
           </a:bodyPr>
           <a:lstStyle/>
           <a:p>
-            <a:pPr algn="ctr">
-              <a:spcBef>
-                <a:spcPts val="0"/>
-              </a:spcBef>
-              <a:spcAft>
-                <a:spcPts val="0"/>
-              </a:spcAft>
-            </a:pPr>
-            <a:r>
-              <a:rPr sz="2600" b="1">
-                <a:solidFill>
-                  <a:srgbClr val="FFFFFF"/>
-                </a:solidFill>
-                <a:latin typeface="Calibri"/>
-              </a:rPr>
-              <a:t>2</a:t>
-            </a:r>
-          </a:p>
-        </p:txBody>
-      </p:sp>
-      <p:sp>
-        <p:nvSpPr>
-          <p:cNvPr id="12" name="Rectangle 11"/>
+            <a:pPr algn="l">
+              <a:spcBef>
+                <a:spcPts val="0"/>
+              </a:spcBef>
+              <a:spcAft>
+                <a:spcPts val="100"/>
+              </a:spcAft>
+            </a:pPr>
+            <a:r>
+              <a:rPr sz="1300" b="1">
+                <a:solidFill>
+                  <a:srgbClr val="0B0B0C"/>
+                </a:solidFill>
+                <a:latin typeface="Calibri"/>
+              </a:rPr>
+              <a:t>Main image appears</a:t>
+            </a:r>
+          </a:p>
+          <a:p>
+            <a:pPr algn="l">
+              <a:spcBef>
+                <a:spcPts val="0"/>
+              </a:spcBef>
+              <a:spcAft>
+                <a:spcPts val="0"/>
+              </a:spcAft>
+            </a:pPr>
+            <a:r>
+              <a:rPr sz="1200" b="1">
+                <a:solidFill>
+                  <a:srgbClr val="1A7F37"/>
+                </a:solidFill>
+                <a:latin typeface="Calibri"/>
+              </a:rPr>
+              <a:t>12.4s → 2.3s</a:t>
+            </a:r>
+          </a:p>
+        </p:txBody>
+      </p:sp>
+      <p:sp>
+        <p:nvSpPr>
+          <p:cNvPr id="14" name="TextBox 13"/>
+          <p:cNvSpPr txBox="1"/>
+          <p:nvPr/>
+        </p:nvSpPr>
+        <p:spPr>
+          <a:xfrm>
+            <a:off x="3657600" y="2651759"/>
+            <a:ext cx="7772400" cy="713232"/>
+          </a:xfrm>
+          <a:prstGeom prst="rect">
+            <a:avLst/>
+          </a:prstGeom>
+          <a:noFill/>
+        </p:spPr>
+        <p:txBody>
+          <a:bodyPr wrap="square" anchor="ctr">
+            <a:spAutoFit/>
+          </a:bodyPr>
+          <a:lstStyle/>
+          <a:p>
+            <a:pPr algn="l">
+              <a:spcBef>
+                <a:spcPts val="0"/>
+              </a:spcBef>
+              <a:spcAft>
+                <a:spcPts val="0"/>
+              </a:spcAft>
+            </a:pPr>
+            <a:r>
+              <a:rPr sz="1250" b="0">
+                <a:solidFill>
+                  <a:srgbClr val="16335C"/>
+                </a:solidFill>
+                <a:latin typeface="Calibri"/>
+              </a:rPr>
+              <a:t>How long before the main content shows on a phone. It took over 12 seconds; now about 2. Most people won't wait past 3.</a:t>
+            </a:r>
+          </a:p>
+        </p:txBody>
+      </p:sp>
+      <p:sp>
+        <p:nvSpPr>
+          <p:cNvPr id="15" name="Rectangle 14"/>
           <p:cNvSpPr/>
           <p:nvPr/>
         </p:nvSpPr>
         <p:spPr>
           <a:xfrm>
-            <a:off x="1325880" y="2560320"/>
-            <a:ext cx="10287000" cy="777240"/>
+            <a:off x="548640" y="3428999"/>
+            <a:ext cx="11064240" cy="713232"/>
           </a:xfrm>
           <a:prstGeom prst="rect">
             <a:avLst/>
@@ -6057,81 +6205,20 @@
       </p:sp>
       <p:sp>
         <p:nvSpPr>
-          <p:cNvPr id="13" name="TextBox 12"/>
-          <p:cNvSpPr txBox="1"/>
-          <p:nvPr/>
-        </p:nvSpPr>
-        <p:spPr>
-          <a:xfrm>
-            <a:off x="1554480" y="2633472"/>
-            <a:ext cx="9875520" cy="685800"/>
-          </a:xfrm>
-          <a:prstGeom prst="rect">
-            <a:avLst/>
-          </a:prstGeom>
-          <a:noFill/>
-        </p:spPr>
-        <p:txBody>
-          <a:bodyPr wrap="square" anchor="ctr">
-            <a:spAutoFit/>
-          </a:bodyPr>
-          <a:lstStyle/>
-          <a:p>
-            <a:pPr algn="l">
-              <a:spcBef>
-                <a:spcPts val="0"/>
-              </a:spcBef>
-              <a:spcAft>
-                <a:spcPts val="200"/>
-              </a:spcAft>
-            </a:pPr>
-            <a:r>
-              <a:rPr sz="1600" b="1">
-                <a:solidFill>
-                  <a:srgbClr val="0B0B0C"/>
-                </a:solidFill>
-                <a:latin typeface="Calibri"/>
-              </a:rPr>
-              <a:t>Check &amp; enhance SEO</a:t>
-            </a:r>
-          </a:p>
-          <a:p>
-            <a:pPr algn="l">
-              <a:spcBef>
-                <a:spcPts val="0"/>
-              </a:spcBef>
-              <a:spcAft>
-                <a:spcPts val="0"/>
-              </a:spcAft>
-            </a:pPr>
-            <a:r>
-              <a:rPr sz="1250" b="0">
-                <a:solidFill>
-                  <a:srgbClr val="5B626D"/>
-                </a:solidFill>
-                <a:latin typeface="Calibri"/>
-              </a:rPr>
-              <a:t>Foundations + audit tooling built</a:t>
-            </a:r>
-          </a:p>
-        </p:txBody>
-      </p:sp>
-      <p:sp>
-        <p:nvSpPr>
-          <p:cNvPr id="14" name="Rectangle 13"/>
+          <p:cNvPr id="16" name="Rectangle 15"/>
           <p:cNvSpPr/>
           <p:nvPr/>
         </p:nvSpPr>
         <p:spPr>
           <a:xfrm>
-            <a:off x="548640" y="3474720"/>
-            <a:ext cx="685800" cy="777240"/>
+            <a:off x="548640" y="3428999"/>
+            <a:ext cx="91440" cy="713232"/>
           </a:xfrm>
           <a:prstGeom prst="rect">
             <a:avLst/>
           </a:prstGeom>
           <a:solidFill>
-            <a:srgbClr val="5B626D"/>
+            <a:srgbClr val="1D4ED8"/>
           </a:solidFill>
           <a:ln>
             <a:noFill/>
@@ -6162,14 +6249,14 @@
       </p:sp>
       <p:sp>
         <p:nvSpPr>
-          <p:cNvPr id="15" name="TextBox 14"/>
+          <p:cNvPr id="17" name="TextBox 16"/>
           <p:cNvSpPr txBox="1"/>
           <p:nvPr/>
         </p:nvSpPr>
         <p:spPr>
           <a:xfrm>
-            <a:off x="548640" y="3474720"/>
-            <a:ext cx="685800" cy="777240"/>
+            <a:off x="777240" y="3428999"/>
+            <a:ext cx="2743200" cy="713232"/>
           </a:xfrm>
           <a:prstGeom prst="rect">
             <a:avLst/>
@@ -6182,36 +6269,97 @@
           </a:bodyPr>
           <a:lstStyle/>
           <a:p>
-            <a:pPr algn="ctr">
-              <a:spcBef>
-                <a:spcPts val="0"/>
-              </a:spcBef>
-              <a:spcAft>
-                <a:spcPts val="0"/>
-              </a:spcAft>
-            </a:pPr>
-            <a:r>
-              <a:rPr sz="2600" b="1">
-                <a:solidFill>
-                  <a:srgbClr val="FFFFFF"/>
-                </a:solidFill>
-                <a:latin typeface="Calibri"/>
-              </a:rPr>
-              <a:t>3</a:t>
-            </a:r>
-          </a:p>
-        </p:txBody>
-      </p:sp>
-      <p:sp>
-        <p:nvSpPr>
-          <p:cNvPr id="16" name="Rectangle 15"/>
+            <a:pPr algn="l">
+              <a:spcBef>
+                <a:spcPts val="0"/>
+              </a:spcBef>
+              <a:spcAft>
+                <a:spcPts val="100"/>
+              </a:spcAft>
+            </a:pPr>
+            <a:r>
+              <a:rPr sz="1300" b="1">
+                <a:solidFill>
+                  <a:srgbClr val="0B0B0C"/>
+                </a:solidFill>
+                <a:latin typeface="Calibri"/>
+              </a:rPr>
+              <a:t>Page responds to taps</a:t>
+            </a:r>
+          </a:p>
+          <a:p>
+            <a:pPr algn="l">
+              <a:spcBef>
+                <a:spcPts val="0"/>
+              </a:spcBef>
+              <a:spcAft>
+                <a:spcPts val="0"/>
+              </a:spcAft>
+            </a:pPr>
+            <a:r>
+              <a:rPr sz="1200" b="1">
+                <a:solidFill>
+                  <a:srgbClr val="1A7F37"/>
+                </a:solidFill>
+                <a:latin typeface="Calibri"/>
+              </a:rPr>
+              <a:t>3.3s → instant</a:t>
+            </a:r>
+          </a:p>
+        </p:txBody>
+      </p:sp>
+      <p:sp>
+        <p:nvSpPr>
+          <p:cNvPr id="18" name="TextBox 17"/>
+          <p:cNvSpPr txBox="1"/>
+          <p:nvPr/>
+        </p:nvSpPr>
+        <p:spPr>
+          <a:xfrm>
+            <a:off x="3657600" y="3428999"/>
+            <a:ext cx="7772400" cy="713232"/>
+          </a:xfrm>
+          <a:prstGeom prst="rect">
+            <a:avLst/>
+          </a:prstGeom>
+          <a:noFill/>
+        </p:spPr>
+        <p:txBody>
+          <a:bodyPr wrap="square" anchor="ctr">
+            <a:spAutoFit/>
+          </a:bodyPr>
+          <a:lstStyle/>
+          <a:p>
+            <a:pPr algn="l">
+              <a:spcBef>
+                <a:spcPts val="0"/>
+              </a:spcBef>
+              <a:spcAft>
+                <a:spcPts val="0"/>
+              </a:spcAft>
+            </a:pPr>
+            <a:r>
+              <a:rPr sz="1250" b="0">
+                <a:solidFill>
+                  <a:srgbClr val="16335C"/>
+                </a:solidFill>
+                <a:latin typeface="Calibri"/>
+              </a:rPr>
+              <a:t>How long the page is frozen and ignores taps while loading. It used to lock up for ~3 seconds; now it reacts straight away.</a:t>
+            </a:r>
+          </a:p>
+        </p:txBody>
+      </p:sp>
+      <p:sp>
+        <p:nvSpPr>
+          <p:cNvPr id="19" name="Rectangle 18"/>
           <p:cNvSpPr/>
           <p:nvPr/>
         </p:nvSpPr>
         <p:spPr>
           <a:xfrm>
-            <a:off x="1325880" y="3474720"/>
-            <a:ext cx="10287000" cy="777240"/>
+            <a:off x="548640" y="4206239"/>
+            <a:ext cx="11064240" cy="713232"/>
           </a:xfrm>
           <a:prstGeom prst="rect">
             <a:avLst/>
@@ -6248,81 +6396,20 @@
       </p:sp>
       <p:sp>
         <p:nvSpPr>
-          <p:cNvPr id="17" name="TextBox 16"/>
-          <p:cNvSpPr txBox="1"/>
-          <p:nvPr/>
-        </p:nvSpPr>
-        <p:spPr>
-          <a:xfrm>
-            <a:off x="1554480" y="3547872"/>
-            <a:ext cx="9875520" cy="685800"/>
-          </a:xfrm>
-          <a:prstGeom prst="rect">
-            <a:avLst/>
-          </a:prstGeom>
-          <a:noFill/>
-        </p:spPr>
-        <p:txBody>
-          <a:bodyPr wrap="square" anchor="ctr">
-            <a:spAutoFit/>
-          </a:bodyPr>
-          <a:lstStyle/>
-          <a:p>
-            <a:pPr algn="l">
-              <a:spcBef>
-                <a:spcPts val="0"/>
-              </a:spcBef>
-              <a:spcAft>
-                <a:spcPts val="200"/>
-              </a:spcAft>
-            </a:pPr>
-            <a:r>
-              <a:rPr sz="1600" b="1">
-                <a:solidFill>
-                  <a:srgbClr val="0B0B0C"/>
-                </a:solidFill>
-                <a:latin typeface="Calibri"/>
-              </a:rPr>
-              <a:t>Launch — migrate the new site to live</a:t>
-            </a:r>
-          </a:p>
-          <a:p>
-            <a:pPr algn="l">
-              <a:spcBef>
-                <a:spcPts val="0"/>
-              </a:spcBef>
-              <a:spcAft>
-                <a:spcPts val="0"/>
-              </a:spcAft>
-            </a:pPr>
-            <a:r>
-              <a:rPr sz="1250" b="0">
-                <a:solidFill>
-                  <a:srgbClr val="5B626D"/>
-                </a:solidFill>
-                <a:latin typeface="Calibri"/>
-              </a:rPr>
-              <a:t>Runbook prepared</a:t>
-            </a:r>
-          </a:p>
-        </p:txBody>
-      </p:sp>
-      <p:sp>
-        <p:nvSpPr>
-          <p:cNvPr id="18" name="Rectangle 17"/>
+          <p:cNvPr id="20" name="Rectangle 19"/>
           <p:cNvSpPr/>
           <p:nvPr/>
         </p:nvSpPr>
         <p:spPr>
           <a:xfrm>
-            <a:off x="548640" y="4389120"/>
-            <a:ext cx="685800" cy="777240"/>
+            <a:off x="548640" y="4206239"/>
+            <a:ext cx="91440" cy="713232"/>
           </a:xfrm>
           <a:prstGeom prst="rect">
             <a:avLst/>
           </a:prstGeom>
           <a:solidFill>
-            <a:srgbClr val="1A7F37"/>
+            <a:srgbClr val="1D4ED8"/>
           </a:solidFill>
           <a:ln>
             <a:noFill/>
@@ -6353,14 +6440,14 @@
       </p:sp>
       <p:sp>
         <p:nvSpPr>
-          <p:cNvPr id="19" name="TextBox 18"/>
+          <p:cNvPr id="21" name="TextBox 20"/>
           <p:cNvSpPr txBox="1"/>
           <p:nvPr/>
         </p:nvSpPr>
         <p:spPr>
           <a:xfrm>
-            <a:off x="548640" y="4389120"/>
-            <a:ext cx="685800" cy="777240"/>
+            <a:off x="777240" y="4206239"/>
+            <a:ext cx="2743200" cy="713232"/>
           </a:xfrm>
           <a:prstGeom prst="rect">
             <a:avLst/>
@@ -6373,36 +6460,97 @@
           </a:bodyPr>
           <a:lstStyle/>
           <a:p>
-            <a:pPr algn="ctr">
-              <a:spcBef>
-                <a:spcPts val="0"/>
-              </a:spcBef>
-              <a:spcAft>
-                <a:spcPts val="0"/>
-              </a:spcAft>
-            </a:pPr>
-            <a:r>
-              <a:rPr sz="2600" b="1">
-                <a:solidFill>
-                  <a:srgbClr val="FFFFFF"/>
-                </a:solidFill>
-                <a:latin typeface="Calibri"/>
-              </a:rPr>
-              <a:t>4</a:t>
-            </a:r>
-          </a:p>
-        </p:txBody>
-      </p:sp>
-      <p:sp>
-        <p:nvSpPr>
-          <p:cNvPr id="20" name="Rectangle 19"/>
+            <a:pPr algn="l">
+              <a:spcBef>
+                <a:spcPts val="0"/>
+              </a:spcBef>
+              <a:spcAft>
+                <a:spcPts val="100"/>
+              </a:spcAft>
+            </a:pPr>
+            <a:r>
+              <a:rPr sz="1300" b="1">
+                <a:solidFill>
+                  <a:srgbClr val="0B0B0C"/>
+                </a:solidFill>
+                <a:latin typeface="Calibri"/>
+              </a:rPr>
+              <a:t>Page looks finished</a:t>
+            </a:r>
+          </a:p>
+          <a:p>
+            <a:pPr algn="l">
+              <a:spcBef>
+                <a:spcPts val="0"/>
+              </a:spcBef>
+              <a:spcAft>
+                <a:spcPts val="0"/>
+              </a:spcAft>
+            </a:pPr>
+            <a:r>
+              <a:rPr sz="1200" b="1">
+                <a:solidFill>
+                  <a:srgbClr val="1A7F37"/>
+                </a:solidFill>
+                <a:latin typeface="Calibri"/>
+              </a:rPr>
+              <a:t>12.1s → 5.6s</a:t>
+            </a:r>
+          </a:p>
+        </p:txBody>
+      </p:sp>
+      <p:sp>
+        <p:nvSpPr>
+          <p:cNvPr id="22" name="TextBox 21"/>
+          <p:cNvSpPr txBox="1"/>
+          <p:nvPr/>
+        </p:nvSpPr>
+        <p:spPr>
+          <a:xfrm>
+            <a:off x="3657600" y="4206239"/>
+            <a:ext cx="7772400" cy="713232"/>
+          </a:xfrm>
+          <a:prstGeom prst="rect">
+            <a:avLst/>
+          </a:prstGeom>
+          <a:noFill/>
+        </p:spPr>
+        <p:txBody>
+          <a:bodyPr wrap="square" anchor="ctr">
+            <a:spAutoFit/>
+          </a:bodyPr>
+          <a:lstStyle/>
+          <a:p>
+            <a:pPr algn="l">
+              <a:spcBef>
+                <a:spcPts val="0"/>
+              </a:spcBef>
+              <a:spcAft>
+                <a:spcPts val="0"/>
+              </a:spcAft>
+            </a:pPr>
+            <a:r>
+              <a:rPr sz="1250" b="0">
+                <a:solidFill>
+                  <a:srgbClr val="16335C"/>
+                </a:solidFill>
+                <a:latin typeface="Calibri"/>
+              </a:rPr>
+              <a:t>How quickly the page visually fills in and looks done — now less than half the time.</a:t>
+            </a:r>
+          </a:p>
+        </p:txBody>
+      </p:sp>
+      <p:sp>
+        <p:nvSpPr>
+          <p:cNvPr id="23" name="Rectangle 22"/>
           <p:cNvSpPr/>
           <p:nvPr/>
         </p:nvSpPr>
         <p:spPr>
           <a:xfrm>
-            <a:off x="1325880" y="4389120"/>
-            <a:ext cx="10287000" cy="777240"/>
+            <a:off x="548640" y="4983479"/>
+            <a:ext cx="11064240" cy="713232"/>
           </a:xfrm>
           <a:prstGeom prst="rect">
             <a:avLst/>
@@ -6439,81 +6587,20 @@
       </p:sp>
       <p:sp>
         <p:nvSpPr>
-          <p:cNvPr id="21" name="TextBox 20"/>
-          <p:cNvSpPr txBox="1"/>
-          <p:nvPr/>
-        </p:nvSpPr>
-        <p:spPr>
-          <a:xfrm>
-            <a:off x="1554480" y="4462272"/>
-            <a:ext cx="9875520" cy="685800"/>
-          </a:xfrm>
-          <a:prstGeom prst="rect">
-            <a:avLst/>
-          </a:prstGeom>
-          <a:noFill/>
-        </p:spPr>
-        <p:txBody>
-          <a:bodyPr wrap="square" anchor="ctr">
-            <a:spAutoFit/>
-          </a:bodyPr>
-          <a:lstStyle/>
-          <a:p>
-            <a:pPr algn="l">
-              <a:spcBef>
-                <a:spcPts val="0"/>
-              </a:spcBef>
-              <a:spcAft>
-                <a:spcPts val="200"/>
-              </a:spcAft>
-            </a:pPr>
-            <a:r>
-              <a:rPr sz="1600" b="1">
-                <a:solidFill>
-                  <a:srgbClr val="0B0B0C"/>
-                </a:solidFill>
-                <a:latin typeface="Calibri"/>
-              </a:rPr>
-              <a:t>Feature &amp; enhanced pages</a:t>
-            </a:r>
-          </a:p>
-          <a:p>
-            <a:pPr algn="l">
-              <a:spcBef>
-                <a:spcPts val="0"/>
-              </a:spcBef>
-              <a:spcAft>
-                <a:spcPts val="0"/>
-              </a:spcAft>
-            </a:pPr>
-            <a:r>
-              <a:rPr sz="1250" b="0">
-                <a:solidFill>
-                  <a:srgbClr val="5B626D"/>
-                </a:solidFill>
-                <a:latin typeface="Calibri"/>
-              </a:rPr>
-              <a:t>Built (Casambi, Fire Safety, Trade, …)</a:t>
-            </a:r>
-          </a:p>
-        </p:txBody>
-      </p:sp>
-      <p:sp>
-        <p:nvSpPr>
-          <p:cNvPr id="22" name="Rectangle 21"/>
+          <p:cNvPr id="24" name="Rectangle 23"/>
           <p:cNvSpPr/>
           <p:nvPr/>
         </p:nvSpPr>
         <p:spPr>
           <a:xfrm>
-            <a:off x="548640" y="5303520"/>
-            <a:ext cx="685800" cy="777240"/>
+            <a:off x="548640" y="4983479"/>
+            <a:ext cx="91440" cy="713232"/>
           </a:xfrm>
           <a:prstGeom prst="rect">
             <a:avLst/>
           </a:prstGeom>
           <a:solidFill>
-            <a:srgbClr val="5B626D"/>
+            <a:srgbClr val="1D4ED8"/>
           </a:solidFill>
           <a:ln>
             <a:noFill/>
@@ -6544,14 +6631,14 @@
       </p:sp>
       <p:sp>
         <p:nvSpPr>
-          <p:cNvPr id="23" name="TextBox 22"/>
+          <p:cNvPr id="25" name="TextBox 24"/>
           <p:cNvSpPr txBox="1"/>
           <p:nvPr/>
         </p:nvSpPr>
         <p:spPr>
           <a:xfrm>
-            <a:off x="548640" y="5303520"/>
-            <a:ext cx="685800" cy="777240"/>
+            <a:off x="777240" y="4983479"/>
+            <a:ext cx="2743200" cy="713232"/>
           </a:xfrm>
           <a:prstGeom prst="rect">
             <a:avLst/>
@@ -6564,42 +6651,103 @@
           </a:bodyPr>
           <a:lstStyle/>
           <a:p>
-            <a:pPr algn="ctr">
-              <a:spcBef>
-                <a:spcPts val="0"/>
-              </a:spcBef>
-              <a:spcAft>
-                <a:spcPts val="0"/>
-              </a:spcAft>
-            </a:pPr>
-            <a:r>
-              <a:rPr sz="2600" b="1">
-                <a:solidFill>
-                  <a:srgbClr val="FFFFFF"/>
-                </a:solidFill>
-                <a:latin typeface="Calibri"/>
-              </a:rPr>
-              <a:t>5</a:t>
-            </a:r>
-          </a:p>
-        </p:txBody>
-      </p:sp>
-      <p:sp>
-        <p:nvSpPr>
-          <p:cNvPr id="24" name="Rectangle 23"/>
+            <a:pPr algn="l">
+              <a:spcBef>
+                <a:spcPts val="0"/>
+              </a:spcBef>
+              <a:spcAft>
+                <a:spcPts val="100"/>
+              </a:spcAft>
+            </a:pPr>
+            <a:r>
+              <a:rPr sz="1300" b="1">
+                <a:solidFill>
+                  <a:srgbClr val="0B0B0C"/>
+                </a:solidFill>
+                <a:latin typeface="Calibri"/>
+              </a:rPr>
+              <a:t>You see something</a:t>
+            </a:r>
+          </a:p>
+          <a:p>
+            <a:pPr algn="l">
+              <a:spcBef>
+                <a:spcPts val="0"/>
+              </a:spcBef>
+              <a:spcAft>
+                <a:spcPts val="0"/>
+              </a:spcAft>
+            </a:pPr>
+            <a:r>
+              <a:rPr sz="1200" b="1">
+                <a:solidFill>
+                  <a:srgbClr val="1A7F37"/>
+                </a:solidFill>
+                <a:latin typeface="Calibri"/>
+              </a:rPr>
+              <a:t>2.8s → 1.2s</a:t>
+            </a:r>
+          </a:p>
+        </p:txBody>
+      </p:sp>
+      <p:sp>
+        <p:nvSpPr>
+          <p:cNvPr id="26" name="TextBox 25"/>
+          <p:cNvSpPr txBox="1"/>
+          <p:nvPr/>
+        </p:nvSpPr>
+        <p:spPr>
+          <a:xfrm>
+            <a:off x="3657600" y="4983479"/>
+            <a:ext cx="7772400" cy="713232"/>
+          </a:xfrm>
+          <a:prstGeom prst="rect">
+            <a:avLst/>
+          </a:prstGeom>
+          <a:noFill/>
+        </p:spPr>
+        <p:txBody>
+          <a:bodyPr wrap="square" anchor="ctr">
+            <a:spAutoFit/>
+          </a:bodyPr>
+          <a:lstStyle/>
+          <a:p>
+            <a:pPr algn="l">
+              <a:spcBef>
+                <a:spcPts val="0"/>
+              </a:spcBef>
+              <a:spcAft>
+                <a:spcPts val="0"/>
+              </a:spcAft>
+            </a:pPr>
+            <a:r>
+              <a:rPr sz="1250" b="0">
+                <a:solidFill>
+                  <a:srgbClr val="16335C"/>
+                </a:solidFill>
+                <a:latin typeface="Calibri"/>
+              </a:rPr>
+              <a:t>How soon anything at all appears on screen, so it doesn't feel blank.</a:t>
+            </a:r>
+          </a:p>
+        </p:txBody>
+      </p:sp>
+      <p:sp>
+        <p:nvSpPr>
+          <p:cNvPr id="27" name="Rectangle 26"/>
           <p:cNvSpPr/>
           <p:nvPr/>
         </p:nvSpPr>
         <p:spPr>
           <a:xfrm>
-            <a:off x="1325880" y="5303520"/>
-            <a:ext cx="10287000" cy="777240"/>
+            <a:off x="548640" y="5897880"/>
+            <a:ext cx="11064240" cy="566928"/>
           </a:xfrm>
           <a:prstGeom prst="rect">
             <a:avLst/>
           </a:prstGeom>
           <a:solidFill>
-            <a:srgbClr val="F4F6F8"/>
+            <a:srgbClr val="16335C"/>
           </a:solidFill>
           <a:ln>
             <a:noFill/>
@@ -6630,14 +6778,14 @@
       </p:sp>
       <p:sp>
         <p:nvSpPr>
-          <p:cNvPr id="25" name="TextBox 24"/>
+          <p:cNvPr id="28" name="TextBox 27"/>
           <p:cNvSpPr txBox="1"/>
           <p:nvPr/>
         </p:nvSpPr>
         <p:spPr>
           <a:xfrm>
-            <a:off x="1554480" y="5376672"/>
-            <a:ext cx="9875520" cy="685800"/>
+            <a:off x="777240" y="5897880"/>
+            <a:ext cx="10607040" cy="566928"/>
           </a:xfrm>
           <a:prstGeom prst="rect">
             <a:avLst/>
@@ -6655,43 +6803,24 @@
                 <a:spcPts val="0"/>
               </a:spcBef>
               <a:spcAft>
-                <a:spcPts val="200"/>
-              </a:spcAft>
-            </a:pPr>
-            <a:r>
-              <a:rPr sz="1600" b="1">
-                <a:solidFill>
-                  <a:srgbClr val="0B0B0C"/>
-                </a:solidFill>
-                <a:latin typeface="Calibri"/>
-              </a:rPr>
-              <a:t>Reconnect live product data</a:t>
-            </a:r>
-          </a:p>
-          <a:p>
-            <a:pPr algn="l">
-              <a:spcBef>
-                <a:spcPts val="0"/>
-              </a:spcBef>
-              <a:spcAft>
-                <a:spcPts val="0"/>
-              </a:spcAft>
-            </a:pPr>
-            <a:r>
-              <a:rPr sz="1250" b="0">
-                <a:solidFill>
-                  <a:srgbClr val="5B626D"/>
-                </a:solidFill>
-                <a:latin typeface="Calibri"/>
-              </a:rPr>
-              <a:t>Final step, switched on last</a:t>
-            </a:r>
-          </a:p>
-        </p:txBody>
-      </p:sp>
-      <p:sp>
-        <p:nvSpPr>
-          <p:cNvPr id="26" name="TextBox 25"/>
+                <a:spcPts val="0"/>
+              </a:spcAft>
+            </a:pPr>
+            <a:r>
+              <a:rPr sz="1250" b="1">
+                <a:solidFill>
+                  <a:srgbClr val="FFFFFF"/>
+                </a:solidFill>
+                <a:latin typeface="Calibri"/>
+              </a:rPr>
+              <a:t>Bottom line: the old site was slow enough on phones to push visitors away; the new one loads fast and stays responsive — which means better Google rankings and more enquiries.</a:t>
+            </a:r>
+          </a:p>
+        </p:txBody>
+      </p:sp>
+      <p:sp>
+        <p:nvSpPr>
+          <p:cNvPr id="29" name="TextBox 28"/>
           <p:cNvSpPr txBox="1"/>
           <p:nvPr/>
         </p:nvSpPr>
@@ -6733,7 +6862,7 @@
       </p:sp>
       <p:sp>
         <p:nvSpPr>
-          <p:cNvPr id="27" name="TextBox 26"/>
+          <p:cNvPr id="30" name="TextBox 29"/>
           <p:cNvSpPr txBox="1"/>
           <p:nvPr/>
         </p:nvSpPr>
@@ -6768,7 +6897,7 @@
                 </a:solidFill>
                 <a:latin typeface="Calibri"/>
               </a:rPr>
-              <a:t>12</a:t>
+              <a:t>11</a:t>
             </a:r>
           </a:p>
         </p:txBody>
@@ -6916,7 +7045,7 @@
                 </a:solidFill>
                 <a:latin typeface="Calibri"/>
               </a:rPr>
-              <a:t>THE BOTTOM LINE</a:t>
+              <a:t>ROADMAP</a:t>
             </a:r>
           </a:p>
           <a:p>
@@ -6935,7 +7064,7 @@
                 </a:solidFill>
                 <a:latin typeface="Calibri"/>
               </a:rPr>
-              <a:t>Old site vs new site</a:t>
+              <a:t>Where we are</a:t>
             </a:r>
           </a:p>
         </p:txBody>
@@ -6992,52 +7121,8 @@
         </p:nvSpPr>
         <p:spPr>
           <a:xfrm>
-            <a:off x="548640" y="1417320"/>
-            <a:ext cx="5486400" cy="457200"/>
-          </a:xfrm>
-          <a:prstGeom prst="rect">
-            <a:avLst/>
-          </a:prstGeom>
-          <a:solidFill>
-            <a:srgbClr val="0B0B0C"/>
-          </a:solidFill>
-          <a:ln>
-            <a:noFill/>
-          </a:ln>
-          <a:effectLst/>
-        </p:spPr>
-        <p:style>
-          <a:lnRef idx="1">
-            <a:schemeClr val="accent1"/>
-          </a:lnRef>
-          <a:fillRef idx="3">
-            <a:schemeClr val="accent1"/>
-          </a:fillRef>
-          <a:effectRef idx="2">
-            <a:schemeClr val="accent1"/>
-          </a:effectRef>
-          <a:fontRef idx="minor">
-            <a:schemeClr val="lt1"/>
-          </a:fontRef>
-        </p:style>
-        <p:txBody>
-          <a:bodyPr rtlCol="0" anchor="ctr"/>
-          <a:lstStyle/>
-          <a:p>
-            <a:pPr algn="ctr"/>
-          </a:p>
-        </p:txBody>
-      </p:sp>
-      <p:sp>
-        <p:nvSpPr>
-          <p:cNvPr id="7" name="Rectangle 6"/>
-          <p:cNvSpPr/>
-          <p:nvPr/>
-        </p:nvSpPr>
-        <p:spPr>
-          <a:xfrm>
-            <a:off x="6126480" y="1417320"/>
-            <a:ext cx="5486400" cy="457200"/>
+            <a:off x="548640" y="1645920"/>
+            <a:ext cx="685800" cy="777240"/>
           </a:xfrm>
           <a:prstGeom prst="rect">
             <a:avLst/>
@@ -7074,14 +7159,14 @@
       </p:sp>
       <p:sp>
         <p:nvSpPr>
-          <p:cNvPr id="8" name="TextBox 7"/>
+          <p:cNvPr id="7" name="TextBox 6"/>
           <p:cNvSpPr txBox="1"/>
           <p:nvPr/>
         </p:nvSpPr>
         <p:spPr>
           <a:xfrm>
-            <a:off x="731520" y="1417320"/>
-            <a:ext cx="5120640" cy="457200"/>
+            <a:off x="548640" y="1645920"/>
+            <a:ext cx="685800" cy="777240"/>
           </a:xfrm>
           <a:prstGeom prst="rect">
             <a:avLst/>
@@ -7094,250 +7179,36 @@
           </a:bodyPr>
           <a:lstStyle/>
           <a:p>
-            <a:pPr algn="l">
-              <a:spcBef>
-                <a:spcPts val="0"/>
-              </a:spcBef>
-              <a:spcAft>
-                <a:spcPts val="0"/>
-              </a:spcAft>
-            </a:pPr>
-            <a:r>
-              <a:rPr sz="1300" b="1">
+            <a:pPr algn="ctr">
+              <a:spcBef>
+                <a:spcPts val="0"/>
+              </a:spcBef>
+              <a:spcAft>
+                <a:spcPts val="0"/>
+              </a:spcAft>
+            </a:pPr>
+            <a:r>
+              <a:rPr sz="2600" b="1">
                 <a:solidFill>
                   <a:srgbClr val="FFFFFF"/>
                 </a:solidFill>
                 <a:latin typeface="Calibri"/>
               </a:rPr>
-              <a:t>OLD SITE</a:t>
-            </a:r>
-          </a:p>
-        </p:txBody>
-      </p:sp>
-      <p:sp>
-        <p:nvSpPr>
-          <p:cNvPr id="9" name="TextBox 8"/>
-          <p:cNvSpPr txBox="1"/>
-          <p:nvPr/>
-        </p:nvSpPr>
-        <p:spPr>
-          <a:xfrm>
-            <a:off x="6309360" y="1417320"/>
-            <a:ext cx="5120640" cy="457200"/>
-          </a:xfrm>
-          <a:prstGeom prst="rect">
-            <a:avLst/>
-          </a:prstGeom>
-          <a:noFill/>
-        </p:spPr>
-        <p:txBody>
-          <a:bodyPr wrap="square" anchor="ctr">
-            <a:spAutoFit/>
-          </a:bodyPr>
-          <a:lstStyle/>
-          <a:p>
-            <a:pPr algn="l">
-              <a:spcBef>
-                <a:spcPts val="0"/>
-              </a:spcBef>
-              <a:spcAft>
-                <a:spcPts val="0"/>
-              </a:spcAft>
-            </a:pPr>
-            <a:r>
-              <a:rPr sz="1300" b="1">
-                <a:solidFill>
-                  <a:srgbClr val="FFFFFF"/>
-                </a:solidFill>
-                <a:latin typeface="Calibri"/>
-              </a:rPr>
-              <a:t>NEW SITE</a:t>
-            </a:r>
-          </a:p>
-        </p:txBody>
-      </p:sp>
-      <p:sp>
-        <p:nvSpPr>
-          <p:cNvPr id="10" name="Rectangle 9"/>
+              <a:t>1</a:t>
+            </a:r>
+          </a:p>
+        </p:txBody>
+      </p:sp>
+      <p:sp>
+        <p:nvSpPr>
+          <p:cNvPr id="8" name="Rectangle 7"/>
           <p:cNvSpPr/>
           <p:nvPr/>
         </p:nvSpPr>
         <p:spPr>
           <a:xfrm>
-            <a:off x="548640" y="1920240"/>
-            <a:ext cx="5486400" cy="512064"/>
-          </a:xfrm>
-          <a:prstGeom prst="rect">
-            <a:avLst/>
-          </a:prstGeom>
-          <a:solidFill>
-            <a:srgbClr val="FFFFFF"/>
-          </a:solidFill>
-          <a:ln>
-            <a:noFill/>
-          </a:ln>
-          <a:effectLst/>
-        </p:spPr>
-        <p:style>
-          <a:lnRef idx="1">
-            <a:schemeClr val="accent1"/>
-          </a:lnRef>
-          <a:fillRef idx="3">
-            <a:schemeClr val="accent1"/>
-          </a:fillRef>
-          <a:effectRef idx="2">
-            <a:schemeClr val="accent1"/>
-          </a:effectRef>
-          <a:fontRef idx="minor">
-            <a:schemeClr val="lt1"/>
-          </a:fontRef>
-        </p:style>
-        <p:txBody>
-          <a:bodyPr rtlCol="0" anchor="ctr"/>
-          <a:lstStyle/>
-          <a:p>
-            <a:pPr algn="ctr"/>
-          </a:p>
-        </p:txBody>
-      </p:sp>
-      <p:sp>
-        <p:nvSpPr>
-          <p:cNvPr id="11" name="Rectangle 10"/>
-          <p:cNvSpPr/>
-          <p:nvPr/>
-        </p:nvSpPr>
-        <p:spPr>
-          <a:xfrm>
-            <a:off x="6126480" y="1920240"/>
-            <a:ext cx="5486400" cy="512064"/>
-          </a:xfrm>
-          <a:prstGeom prst="rect">
-            <a:avLst/>
-          </a:prstGeom>
-          <a:solidFill>
-            <a:srgbClr val="FFFFFF"/>
-          </a:solidFill>
-          <a:ln>
-            <a:noFill/>
-          </a:ln>
-          <a:effectLst/>
-        </p:spPr>
-        <p:style>
-          <a:lnRef idx="1">
-            <a:schemeClr val="accent1"/>
-          </a:lnRef>
-          <a:fillRef idx="3">
-            <a:schemeClr val="accent1"/>
-          </a:fillRef>
-          <a:effectRef idx="2">
-            <a:schemeClr val="accent1"/>
-          </a:effectRef>
-          <a:fontRef idx="minor">
-            <a:schemeClr val="lt1"/>
-          </a:fontRef>
-        </p:style>
-        <p:txBody>
-          <a:bodyPr rtlCol="0" anchor="ctr"/>
-          <a:lstStyle/>
-          <a:p>
-            <a:pPr algn="ctr"/>
-          </a:p>
-        </p:txBody>
-      </p:sp>
-      <p:sp>
-        <p:nvSpPr>
-          <p:cNvPr id="12" name="TextBox 11"/>
-          <p:cNvSpPr txBox="1"/>
-          <p:nvPr/>
-        </p:nvSpPr>
-        <p:spPr>
-          <a:xfrm>
-            <a:off x="731520" y="1920240"/>
-            <a:ext cx="5212080" cy="512064"/>
-          </a:xfrm>
-          <a:prstGeom prst="rect">
-            <a:avLst/>
-          </a:prstGeom>
-          <a:noFill/>
-        </p:spPr>
-        <p:txBody>
-          <a:bodyPr wrap="square" anchor="ctr">
-            <a:spAutoFit/>
-          </a:bodyPr>
-          <a:lstStyle/>
-          <a:p>
-            <a:pPr algn="l">
-              <a:spcBef>
-                <a:spcPts val="0"/>
-              </a:spcBef>
-              <a:spcAft>
-                <a:spcPts val="0"/>
-              </a:spcAft>
-            </a:pPr>
-            <a:r>
-              <a:rPr sz="1200" b="0">
-                <a:solidFill>
-                  <a:srgbClr val="5B626D"/>
-                </a:solidFill>
-                <a:latin typeface="Calibri"/>
-              </a:rPr>
-              <a:t>248 GB of bloat, 91% duplicate images</a:t>
-            </a:r>
-          </a:p>
-        </p:txBody>
-      </p:sp>
-      <p:sp>
-        <p:nvSpPr>
-          <p:cNvPr id="13" name="TextBox 12"/>
-          <p:cNvSpPr txBox="1"/>
-          <p:nvPr/>
-        </p:nvSpPr>
-        <p:spPr>
-          <a:xfrm>
-            <a:off x="6309360" y="1920240"/>
-            <a:ext cx="5212080" cy="512064"/>
-          </a:xfrm>
-          <a:prstGeom prst="rect">
-            <a:avLst/>
-          </a:prstGeom>
-          <a:noFill/>
-        </p:spPr>
-        <p:txBody>
-          <a:bodyPr wrap="square" anchor="ctr">
-            <a:spAutoFit/>
-          </a:bodyPr>
-          <a:lstStyle/>
-          <a:p>
-            <a:pPr algn="l">
-              <a:spcBef>
-                <a:spcPts val="0"/>
-              </a:spcBef>
-              <a:spcAft>
-                <a:spcPts val="0"/>
-              </a:spcAft>
-            </a:pPr>
-            <a:r>
-              <a:rPr sz="1200" b="1">
-                <a:solidFill>
-                  <a:srgbClr val="16335C"/>
-                </a:solidFill>
-                <a:latin typeface="Calibri"/>
-              </a:rPr>
-              <a:t>Cleaned up, lean media library</a:t>
-            </a:r>
-          </a:p>
-        </p:txBody>
-      </p:sp>
-      <p:sp>
-        <p:nvSpPr>
-          <p:cNvPr id="14" name="Rectangle 13"/>
-          <p:cNvSpPr/>
-          <p:nvPr/>
-        </p:nvSpPr>
-        <p:spPr>
-          <a:xfrm>
-            <a:off x="548640" y="2468880"/>
-            <a:ext cx="5486400" cy="512064"/>
+            <a:off x="1325880" y="1645920"/>
+            <a:ext cx="10287000" cy="777240"/>
           </a:xfrm>
           <a:prstGeom prst="rect">
             <a:avLst/>
@@ -7374,14 +7245,161 @@
       </p:sp>
       <p:sp>
         <p:nvSpPr>
-          <p:cNvPr id="15" name="Rectangle 14"/>
+          <p:cNvPr id="9" name="TextBox 8"/>
+          <p:cNvSpPr txBox="1"/>
+          <p:nvPr/>
+        </p:nvSpPr>
+        <p:spPr>
+          <a:xfrm>
+            <a:off x="1554480" y="1719072"/>
+            <a:ext cx="9875520" cy="685800"/>
+          </a:xfrm>
+          <a:prstGeom prst="rect">
+            <a:avLst/>
+          </a:prstGeom>
+          <a:noFill/>
+        </p:spPr>
+        <p:txBody>
+          <a:bodyPr wrap="square" anchor="ctr">
+            <a:spAutoFit/>
+          </a:bodyPr>
+          <a:lstStyle/>
+          <a:p>
+            <a:pPr algn="l">
+              <a:spcBef>
+                <a:spcPts val="0"/>
+              </a:spcBef>
+              <a:spcAft>
+                <a:spcPts val="200"/>
+              </a:spcAft>
+            </a:pPr>
+            <a:r>
+              <a:rPr sz="1600" b="1">
+                <a:solidFill>
+                  <a:srgbClr val="0B0B0C"/>
+                </a:solidFill>
+                <a:latin typeface="Calibri"/>
+              </a:rPr>
+              <a:t>Recreate ricoman.com exactly on the new platform</a:t>
+            </a:r>
+          </a:p>
+          <a:p>
+            <a:pPr algn="l">
+              <a:spcBef>
+                <a:spcPts val="0"/>
+              </a:spcBef>
+              <a:spcAft>
+                <a:spcPts val="0"/>
+              </a:spcAft>
+            </a:pPr>
+            <a:r>
+              <a:rPr sz="1250" b="0">
+                <a:solidFill>
+                  <a:srgbClr val="5B626D"/>
+                </a:solidFill>
+                <a:latin typeface="Calibri"/>
+              </a:rPr>
+              <a:t>In progress — confirming each page matches live</a:t>
+            </a:r>
+          </a:p>
+        </p:txBody>
+      </p:sp>
+      <p:sp>
+        <p:nvSpPr>
+          <p:cNvPr id="10" name="Rectangle 9"/>
           <p:cNvSpPr/>
           <p:nvPr/>
         </p:nvSpPr>
         <p:spPr>
           <a:xfrm>
-            <a:off x="6126480" y="2468880"/>
-            <a:ext cx="5486400" cy="512064"/>
+            <a:off x="548640" y="2560320"/>
+            <a:ext cx="685800" cy="777240"/>
+          </a:xfrm>
+          <a:prstGeom prst="rect">
+            <a:avLst/>
+          </a:prstGeom>
+          <a:solidFill>
+            <a:srgbClr val="1D4ED8"/>
+          </a:solidFill>
+          <a:ln>
+            <a:noFill/>
+          </a:ln>
+          <a:effectLst/>
+        </p:spPr>
+        <p:style>
+          <a:lnRef idx="1">
+            <a:schemeClr val="accent1"/>
+          </a:lnRef>
+          <a:fillRef idx="3">
+            <a:schemeClr val="accent1"/>
+          </a:fillRef>
+          <a:effectRef idx="2">
+            <a:schemeClr val="accent1"/>
+          </a:effectRef>
+          <a:fontRef idx="minor">
+            <a:schemeClr val="lt1"/>
+          </a:fontRef>
+        </p:style>
+        <p:txBody>
+          <a:bodyPr rtlCol="0" anchor="ctr"/>
+          <a:lstStyle/>
+          <a:p>
+            <a:pPr algn="ctr"/>
+          </a:p>
+        </p:txBody>
+      </p:sp>
+      <p:sp>
+        <p:nvSpPr>
+          <p:cNvPr id="11" name="TextBox 10"/>
+          <p:cNvSpPr txBox="1"/>
+          <p:nvPr/>
+        </p:nvSpPr>
+        <p:spPr>
+          <a:xfrm>
+            <a:off x="548640" y="2560320"/>
+            <a:ext cx="685800" cy="777240"/>
+          </a:xfrm>
+          <a:prstGeom prst="rect">
+            <a:avLst/>
+          </a:prstGeom>
+          <a:noFill/>
+        </p:spPr>
+        <p:txBody>
+          <a:bodyPr wrap="square" anchor="ctr">
+            <a:spAutoFit/>
+          </a:bodyPr>
+          <a:lstStyle/>
+          <a:p>
+            <a:pPr algn="ctr">
+              <a:spcBef>
+                <a:spcPts val="0"/>
+              </a:spcBef>
+              <a:spcAft>
+                <a:spcPts val="0"/>
+              </a:spcAft>
+            </a:pPr>
+            <a:r>
+              <a:rPr sz="2600" b="1">
+                <a:solidFill>
+                  <a:srgbClr val="FFFFFF"/>
+                </a:solidFill>
+                <a:latin typeface="Calibri"/>
+              </a:rPr>
+              <a:t>2</a:t>
+            </a:r>
+          </a:p>
+        </p:txBody>
+      </p:sp>
+      <p:sp>
+        <p:nvSpPr>
+          <p:cNvPr id="12" name="Rectangle 11"/>
+          <p:cNvSpPr/>
+          <p:nvPr/>
+        </p:nvSpPr>
+        <p:spPr>
+          <a:xfrm>
+            <a:off x="1325880" y="2560320"/>
+            <a:ext cx="10287000" cy="777240"/>
           </a:xfrm>
           <a:prstGeom prst="rect">
             <a:avLst/>
@@ -7418,14 +7436,14 @@
       </p:sp>
       <p:sp>
         <p:nvSpPr>
-          <p:cNvPr id="16" name="TextBox 15"/>
+          <p:cNvPr id="13" name="TextBox 12"/>
           <p:cNvSpPr txBox="1"/>
           <p:nvPr/>
         </p:nvSpPr>
         <p:spPr>
           <a:xfrm>
-            <a:off x="731520" y="2468880"/>
-            <a:ext cx="5212080" cy="512064"/>
+            <a:off x="1554480" y="2633472"/>
+            <a:ext cx="9875520" cy="685800"/>
           </a:xfrm>
           <a:prstGeom prst="rect">
             <a:avLst/>
@@ -7443,79 +7461,56 @@
                 <a:spcPts val="0"/>
               </a:spcBef>
               <a:spcAft>
-                <a:spcPts val="0"/>
-              </a:spcAft>
-            </a:pPr>
-            <a:r>
-              <a:rPr sz="1200" b="0">
+                <a:spcPts val="200"/>
+              </a:spcAft>
+            </a:pPr>
+            <a:r>
+              <a:rPr sz="1600" b="1">
+                <a:solidFill>
+                  <a:srgbClr val="0B0B0C"/>
+                </a:solidFill>
+                <a:latin typeface="Calibri"/>
+              </a:rPr>
+              <a:t>Check &amp; enhance SEO</a:t>
+            </a:r>
+          </a:p>
+          <a:p>
+            <a:pPr algn="l">
+              <a:spcBef>
+                <a:spcPts val="0"/>
+              </a:spcBef>
+              <a:spcAft>
+                <a:spcPts val="0"/>
+              </a:spcAft>
+            </a:pPr>
+            <a:r>
+              <a:rPr sz="1250" b="0">
                 <a:solidFill>
                   <a:srgbClr val="5B626D"/>
                 </a:solidFill>
                 <a:latin typeface="Calibri"/>
               </a:rPr>
-              <a:t>Backups failing since ~Oct 2025</a:t>
-            </a:r>
-          </a:p>
-        </p:txBody>
-      </p:sp>
-      <p:sp>
-        <p:nvSpPr>
-          <p:cNvPr id="17" name="TextBox 16"/>
-          <p:cNvSpPr txBox="1"/>
-          <p:nvPr/>
-        </p:nvSpPr>
-        <p:spPr>
-          <a:xfrm>
-            <a:off x="6309360" y="2468880"/>
-            <a:ext cx="5212080" cy="512064"/>
-          </a:xfrm>
-          <a:prstGeom prst="rect">
-            <a:avLst/>
-          </a:prstGeom>
-          <a:noFill/>
-        </p:spPr>
-        <p:txBody>
-          <a:bodyPr wrap="square" anchor="ctr">
-            <a:spAutoFit/>
-          </a:bodyPr>
-          <a:lstStyle/>
-          <a:p>
-            <a:pPr algn="l">
-              <a:spcBef>
-                <a:spcPts val="0"/>
-              </a:spcBef>
-              <a:spcAft>
-                <a:spcPts val="0"/>
-              </a:spcAft>
-            </a:pPr>
-            <a:r>
-              <a:rPr sz="1200" b="1">
-                <a:solidFill>
-                  <a:srgbClr val="16335C"/>
-                </a:solidFill>
-                <a:latin typeface="Calibri"/>
-              </a:rPr>
-              <a:t>Reliable, fast backups</a:t>
-            </a:r>
-          </a:p>
-        </p:txBody>
-      </p:sp>
-      <p:sp>
-        <p:nvSpPr>
-          <p:cNvPr id="18" name="Rectangle 17"/>
+              <a:t>Foundations + audit tooling built</a:t>
+            </a:r>
+          </a:p>
+        </p:txBody>
+      </p:sp>
+      <p:sp>
+        <p:nvSpPr>
+          <p:cNvPr id="14" name="Rectangle 13"/>
           <p:cNvSpPr/>
           <p:nvPr/>
         </p:nvSpPr>
         <p:spPr>
           <a:xfrm>
-            <a:off x="548640" y="3017520"/>
-            <a:ext cx="5486400" cy="512064"/>
+            <a:off x="548640" y="3474720"/>
+            <a:ext cx="685800" cy="777240"/>
           </a:xfrm>
           <a:prstGeom prst="rect">
             <a:avLst/>
           </a:prstGeom>
           <a:solidFill>
-            <a:srgbClr val="FFFFFF"/>
+            <a:srgbClr val="5B626D"/>
           </a:solidFill>
           <a:ln>
             <a:noFill/>
@@ -7546,58 +7541,14 @@
       </p:sp>
       <p:sp>
         <p:nvSpPr>
-          <p:cNvPr id="19" name="Rectangle 18"/>
-          <p:cNvSpPr/>
-          <p:nvPr/>
-        </p:nvSpPr>
-        <p:spPr>
-          <a:xfrm>
-            <a:off x="6126480" y="3017520"/>
-            <a:ext cx="5486400" cy="512064"/>
-          </a:xfrm>
-          <a:prstGeom prst="rect">
-            <a:avLst/>
-          </a:prstGeom>
-          <a:solidFill>
-            <a:srgbClr val="FFFFFF"/>
-          </a:solidFill>
-          <a:ln>
-            <a:noFill/>
-          </a:ln>
-          <a:effectLst/>
-        </p:spPr>
-        <p:style>
-          <a:lnRef idx="1">
-            <a:schemeClr val="accent1"/>
-          </a:lnRef>
-          <a:fillRef idx="3">
-            <a:schemeClr val="accent1"/>
-          </a:fillRef>
-          <a:effectRef idx="2">
-            <a:schemeClr val="accent1"/>
-          </a:effectRef>
-          <a:fontRef idx="minor">
-            <a:schemeClr val="lt1"/>
-          </a:fontRef>
-        </p:style>
-        <p:txBody>
-          <a:bodyPr rtlCol="0" anchor="ctr"/>
-          <a:lstStyle/>
-          <a:p>
-            <a:pPr algn="ctr"/>
-          </a:p>
-        </p:txBody>
-      </p:sp>
-      <p:sp>
-        <p:nvSpPr>
-          <p:cNvPr id="20" name="TextBox 19"/>
+          <p:cNvPr id="15" name="TextBox 14"/>
           <p:cNvSpPr txBox="1"/>
           <p:nvPr/>
         </p:nvSpPr>
         <p:spPr>
           <a:xfrm>
-            <a:off x="731520" y="3017520"/>
-            <a:ext cx="5212080" cy="512064"/>
+            <a:off x="548640" y="3474720"/>
+            <a:ext cx="685800" cy="777240"/>
           </a:xfrm>
           <a:prstGeom prst="rect">
             <a:avLst/>
@@ -7610,78 +7561,36 @@
           </a:bodyPr>
           <a:lstStyle/>
           <a:p>
-            <a:pPr algn="l">
-              <a:spcBef>
-                <a:spcPts val="0"/>
-              </a:spcBef>
-              <a:spcAft>
-                <a:spcPts val="0"/>
-              </a:spcAft>
-            </a:pPr>
-            <a:r>
-              <a:rPr sz="1200" b="0">
-                <a:solidFill>
-                  <a:srgbClr val="5B626D"/>
-                </a:solidFill>
-                <a:latin typeface="Calibri"/>
-              </a:rPr>
-              <a:t>Higher, growing hosting cost</a:t>
-            </a:r>
-          </a:p>
-        </p:txBody>
-      </p:sp>
-      <p:sp>
-        <p:nvSpPr>
-          <p:cNvPr id="21" name="TextBox 20"/>
-          <p:cNvSpPr txBox="1"/>
-          <p:nvPr/>
-        </p:nvSpPr>
-        <p:spPr>
-          <a:xfrm>
-            <a:off x="6309360" y="3017520"/>
-            <a:ext cx="5212080" cy="512064"/>
-          </a:xfrm>
-          <a:prstGeom prst="rect">
-            <a:avLst/>
-          </a:prstGeom>
-          <a:noFill/>
-        </p:spPr>
-        <p:txBody>
-          <a:bodyPr wrap="square" anchor="ctr">
-            <a:spAutoFit/>
-          </a:bodyPr>
-          <a:lstStyle/>
-          <a:p>
-            <a:pPr algn="l">
-              <a:spcBef>
-                <a:spcPts val="0"/>
-              </a:spcBef>
-              <a:spcAft>
-                <a:spcPts val="0"/>
-              </a:spcAft>
-            </a:pPr>
-            <a:r>
-              <a:rPr sz="1200" b="1">
-                <a:solidFill>
-                  <a:srgbClr val="16335C"/>
-                </a:solidFill>
-                <a:latin typeface="Calibri"/>
-              </a:rPr>
-              <a:t>Lower, predictable hosting cost</a:t>
-            </a:r>
-          </a:p>
-        </p:txBody>
-      </p:sp>
-      <p:sp>
-        <p:nvSpPr>
-          <p:cNvPr id="22" name="Rectangle 21"/>
+            <a:pPr algn="ctr">
+              <a:spcBef>
+                <a:spcPts val="0"/>
+              </a:spcBef>
+              <a:spcAft>
+                <a:spcPts val="0"/>
+              </a:spcAft>
+            </a:pPr>
+            <a:r>
+              <a:rPr sz="2600" b="1">
+                <a:solidFill>
+                  <a:srgbClr val="FFFFFF"/>
+                </a:solidFill>
+                <a:latin typeface="Calibri"/>
+              </a:rPr>
+              <a:t>3</a:t>
+            </a:r>
+          </a:p>
+        </p:txBody>
+      </p:sp>
+      <p:sp>
+        <p:nvSpPr>
+          <p:cNvPr id="16" name="Rectangle 15"/>
           <p:cNvSpPr/>
           <p:nvPr/>
         </p:nvSpPr>
         <p:spPr>
           <a:xfrm>
-            <a:off x="548640" y="3566160"/>
-            <a:ext cx="5486400" cy="512064"/>
+            <a:off x="1325880" y="3474720"/>
+            <a:ext cx="10287000" cy="777240"/>
           </a:xfrm>
           <a:prstGeom prst="rect">
             <a:avLst/>
@@ -7718,14 +7627,161 @@
       </p:sp>
       <p:sp>
         <p:nvSpPr>
-          <p:cNvPr id="23" name="Rectangle 22"/>
+          <p:cNvPr id="17" name="TextBox 16"/>
+          <p:cNvSpPr txBox="1"/>
+          <p:nvPr/>
+        </p:nvSpPr>
+        <p:spPr>
+          <a:xfrm>
+            <a:off x="1554480" y="3547872"/>
+            <a:ext cx="9875520" cy="685800"/>
+          </a:xfrm>
+          <a:prstGeom prst="rect">
+            <a:avLst/>
+          </a:prstGeom>
+          <a:noFill/>
+        </p:spPr>
+        <p:txBody>
+          <a:bodyPr wrap="square" anchor="ctr">
+            <a:spAutoFit/>
+          </a:bodyPr>
+          <a:lstStyle/>
+          <a:p>
+            <a:pPr algn="l">
+              <a:spcBef>
+                <a:spcPts val="0"/>
+              </a:spcBef>
+              <a:spcAft>
+                <a:spcPts val="200"/>
+              </a:spcAft>
+            </a:pPr>
+            <a:r>
+              <a:rPr sz="1600" b="1">
+                <a:solidFill>
+                  <a:srgbClr val="0B0B0C"/>
+                </a:solidFill>
+                <a:latin typeface="Calibri"/>
+              </a:rPr>
+              <a:t>Launch — migrate the new site to live</a:t>
+            </a:r>
+          </a:p>
+          <a:p>
+            <a:pPr algn="l">
+              <a:spcBef>
+                <a:spcPts val="0"/>
+              </a:spcBef>
+              <a:spcAft>
+                <a:spcPts val="0"/>
+              </a:spcAft>
+            </a:pPr>
+            <a:r>
+              <a:rPr sz="1250" b="0">
+                <a:solidFill>
+                  <a:srgbClr val="5B626D"/>
+                </a:solidFill>
+                <a:latin typeface="Calibri"/>
+              </a:rPr>
+              <a:t>Runbook prepared</a:t>
+            </a:r>
+          </a:p>
+        </p:txBody>
+      </p:sp>
+      <p:sp>
+        <p:nvSpPr>
+          <p:cNvPr id="18" name="Rectangle 17"/>
           <p:cNvSpPr/>
           <p:nvPr/>
         </p:nvSpPr>
         <p:spPr>
           <a:xfrm>
-            <a:off x="6126480" y="3566160"/>
-            <a:ext cx="5486400" cy="512064"/>
+            <a:off x="548640" y="4389120"/>
+            <a:ext cx="685800" cy="777240"/>
+          </a:xfrm>
+          <a:prstGeom prst="rect">
+            <a:avLst/>
+          </a:prstGeom>
+          <a:solidFill>
+            <a:srgbClr val="1A7F37"/>
+          </a:solidFill>
+          <a:ln>
+            <a:noFill/>
+          </a:ln>
+          <a:effectLst/>
+        </p:spPr>
+        <p:style>
+          <a:lnRef idx="1">
+            <a:schemeClr val="accent1"/>
+          </a:lnRef>
+          <a:fillRef idx="3">
+            <a:schemeClr val="accent1"/>
+          </a:fillRef>
+          <a:effectRef idx="2">
+            <a:schemeClr val="accent1"/>
+          </a:effectRef>
+          <a:fontRef idx="minor">
+            <a:schemeClr val="lt1"/>
+          </a:fontRef>
+        </p:style>
+        <p:txBody>
+          <a:bodyPr rtlCol="0" anchor="ctr"/>
+          <a:lstStyle/>
+          <a:p>
+            <a:pPr algn="ctr"/>
+          </a:p>
+        </p:txBody>
+      </p:sp>
+      <p:sp>
+        <p:nvSpPr>
+          <p:cNvPr id="19" name="TextBox 18"/>
+          <p:cNvSpPr txBox="1"/>
+          <p:nvPr/>
+        </p:nvSpPr>
+        <p:spPr>
+          <a:xfrm>
+            <a:off x="548640" y="4389120"/>
+            <a:ext cx="685800" cy="777240"/>
+          </a:xfrm>
+          <a:prstGeom prst="rect">
+            <a:avLst/>
+          </a:prstGeom>
+          <a:noFill/>
+        </p:spPr>
+        <p:txBody>
+          <a:bodyPr wrap="square" anchor="ctr">
+            <a:spAutoFit/>
+          </a:bodyPr>
+          <a:lstStyle/>
+          <a:p>
+            <a:pPr algn="ctr">
+              <a:spcBef>
+                <a:spcPts val="0"/>
+              </a:spcBef>
+              <a:spcAft>
+                <a:spcPts val="0"/>
+              </a:spcAft>
+            </a:pPr>
+            <a:r>
+              <a:rPr sz="2600" b="1">
+                <a:solidFill>
+                  <a:srgbClr val="FFFFFF"/>
+                </a:solidFill>
+                <a:latin typeface="Calibri"/>
+              </a:rPr>
+              <a:t>4</a:t>
+            </a:r>
+          </a:p>
+        </p:txBody>
+      </p:sp>
+      <p:sp>
+        <p:nvSpPr>
+          <p:cNvPr id="20" name="Rectangle 19"/>
+          <p:cNvSpPr/>
+          <p:nvPr/>
+        </p:nvSpPr>
+        <p:spPr>
+          <a:xfrm>
+            <a:off x="1325880" y="4389120"/>
+            <a:ext cx="10287000" cy="777240"/>
           </a:xfrm>
           <a:prstGeom prst="rect">
             <a:avLst/>
@@ -7762,14 +7818,14 @@
       </p:sp>
       <p:sp>
         <p:nvSpPr>
-          <p:cNvPr id="24" name="TextBox 23"/>
+          <p:cNvPr id="21" name="TextBox 20"/>
           <p:cNvSpPr txBox="1"/>
           <p:nvPr/>
         </p:nvSpPr>
         <p:spPr>
           <a:xfrm>
-            <a:off x="731520" y="3566160"/>
-            <a:ext cx="5212080" cy="512064"/>
+            <a:off x="1554480" y="4462272"/>
+            <a:ext cx="9875520" cy="685800"/>
           </a:xfrm>
           <a:prstGeom prst="rect">
             <a:avLst/>
@@ -7787,79 +7843,56 @@
                 <a:spcPts val="0"/>
               </a:spcBef>
               <a:spcAft>
-                <a:spcPts val="0"/>
-              </a:spcAft>
-            </a:pPr>
-            <a:r>
-              <a:rPr sz="1200" b="0">
+                <a:spcPts val="200"/>
+              </a:spcAft>
+            </a:pPr>
+            <a:r>
+              <a:rPr sz="1600" b="1">
+                <a:solidFill>
+                  <a:srgbClr val="0B0B0C"/>
+                </a:solidFill>
+                <a:latin typeface="Calibri"/>
+              </a:rPr>
+              <a:t>Feature &amp; enhanced pages</a:t>
+            </a:r>
+          </a:p>
+          <a:p>
+            <a:pPr algn="l">
+              <a:spcBef>
+                <a:spcPts val="0"/>
+              </a:spcBef>
+              <a:spcAft>
+                <a:spcPts val="0"/>
+              </a:spcAft>
+            </a:pPr>
+            <a:r>
+              <a:rPr sz="1250" b="0">
                 <a:solidFill>
                   <a:srgbClr val="5B626D"/>
                 </a:solidFill>
                 <a:latin typeface="Calibri"/>
               </a:rPr>
-              <a:t>Changes needed a developer</a:t>
-            </a:r>
-          </a:p>
-        </p:txBody>
-      </p:sp>
-      <p:sp>
-        <p:nvSpPr>
-          <p:cNvPr id="25" name="TextBox 24"/>
-          <p:cNvSpPr txBox="1"/>
-          <p:nvPr/>
-        </p:nvSpPr>
-        <p:spPr>
-          <a:xfrm>
-            <a:off x="6309360" y="3566160"/>
-            <a:ext cx="5212080" cy="512064"/>
-          </a:xfrm>
-          <a:prstGeom prst="rect">
-            <a:avLst/>
-          </a:prstGeom>
-          <a:noFill/>
-        </p:spPr>
-        <p:txBody>
-          <a:bodyPr wrap="square" anchor="ctr">
-            <a:spAutoFit/>
-          </a:bodyPr>
-          <a:lstStyle/>
-          <a:p>
-            <a:pPr algn="l">
-              <a:spcBef>
-                <a:spcPts val="0"/>
-              </a:spcBef>
-              <a:spcAft>
-                <a:spcPts val="0"/>
-              </a:spcAft>
-            </a:pPr>
-            <a:r>
-              <a:rPr sz="1200" b="1">
-                <a:solidFill>
-                  <a:srgbClr val="16335C"/>
-                </a:solidFill>
-                <a:latin typeface="Calibri"/>
-              </a:rPr>
-              <a:t>Team edits products &amp; pages themselves</a:t>
-            </a:r>
-          </a:p>
-        </p:txBody>
-      </p:sp>
-      <p:sp>
-        <p:nvSpPr>
-          <p:cNvPr id="26" name="Rectangle 25"/>
+              <a:t>Built (Casambi, Fire Safety, Trade, …)</a:t>
+            </a:r>
+          </a:p>
+        </p:txBody>
+      </p:sp>
+      <p:sp>
+        <p:nvSpPr>
+          <p:cNvPr id="22" name="Rectangle 21"/>
           <p:cNvSpPr/>
           <p:nvPr/>
         </p:nvSpPr>
         <p:spPr>
           <a:xfrm>
-            <a:off x="548640" y="4114800"/>
-            <a:ext cx="5486400" cy="512064"/>
+            <a:off x="548640" y="5303520"/>
+            <a:ext cx="685800" cy="777240"/>
           </a:xfrm>
           <a:prstGeom prst="rect">
             <a:avLst/>
           </a:prstGeom>
           <a:solidFill>
-            <a:srgbClr val="FFFFFF"/>
+            <a:srgbClr val="5B626D"/>
           </a:solidFill>
           <a:ln>
             <a:noFill/>
@@ -7890,58 +7923,14 @@
       </p:sp>
       <p:sp>
         <p:nvSpPr>
-          <p:cNvPr id="27" name="Rectangle 26"/>
-          <p:cNvSpPr/>
-          <p:nvPr/>
-        </p:nvSpPr>
-        <p:spPr>
-          <a:xfrm>
-            <a:off x="6126480" y="4114800"/>
-            <a:ext cx="5486400" cy="512064"/>
-          </a:xfrm>
-          <a:prstGeom prst="rect">
-            <a:avLst/>
-          </a:prstGeom>
-          <a:solidFill>
-            <a:srgbClr val="FFFFFF"/>
-          </a:solidFill>
-          <a:ln>
-            <a:noFill/>
-          </a:ln>
-          <a:effectLst/>
-        </p:spPr>
-        <p:style>
-          <a:lnRef idx="1">
-            <a:schemeClr val="accent1"/>
-          </a:lnRef>
-          <a:fillRef idx="3">
-            <a:schemeClr val="accent1"/>
-          </a:fillRef>
-          <a:effectRef idx="2">
-            <a:schemeClr val="accent1"/>
-          </a:effectRef>
-          <a:fontRef idx="minor">
-            <a:schemeClr val="lt1"/>
-          </a:fontRef>
-        </p:style>
-        <p:txBody>
-          <a:bodyPr rtlCol="0" anchor="ctr"/>
-          <a:lstStyle/>
-          <a:p>
-            <a:pPr algn="ctr"/>
-          </a:p>
-        </p:txBody>
-      </p:sp>
-      <p:sp>
-        <p:nvSpPr>
-          <p:cNvPr id="28" name="TextBox 27"/>
+          <p:cNvPr id="23" name="TextBox 22"/>
           <p:cNvSpPr txBox="1"/>
           <p:nvPr/>
         </p:nvSpPr>
         <p:spPr>
           <a:xfrm>
-            <a:off x="731520" y="4114800"/>
-            <a:ext cx="5212080" cy="512064"/>
+            <a:off x="548640" y="5303520"/>
+            <a:ext cx="685800" cy="777240"/>
           </a:xfrm>
           <a:prstGeom prst="rect">
             <a:avLst/>
@@ -7954,78 +7943,36 @@
           </a:bodyPr>
           <a:lstStyle/>
           <a:p>
-            <a:pPr algn="l">
-              <a:spcBef>
-                <a:spcPts val="0"/>
-              </a:spcBef>
-              <a:spcAft>
-                <a:spcPts val="0"/>
-              </a:spcAft>
-            </a:pPr>
-            <a:r>
-              <a:rPr sz="1200" b="0">
-                <a:solidFill>
-                  <a:srgbClr val="5B626D"/>
-                </a:solidFill>
-                <a:latin typeface="Calibri"/>
-              </a:rPr>
-              <a:t>A brochure</a:t>
-            </a:r>
-          </a:p>
-        </p:txBody>
-      </p:sp>
-      <p:sp>
-        <p:nvSpPr>
-          <p:cNvPr id="29" name="TextBox 28"/>
-          <p:cNvSpPr txBox="1"/>
-          <p:nvPr/>
-        </p:nvSpPr>
-        <p:spPr>
-          <a:xfrm>
-            <a:off x="6309360" y="4114800"/>
-            <a:ext cx="5212080" cy="512064"/>
-          </a:xfrm>
-          <a:prstGeom prst="rect">
-            <a:avLst/>
-          </a:prstGeom>
-          <a:noFill/>
-        </p:spPr>
-        <p:txBody>
-          <a:bodyPr wrap="square" anchor="ctr">
-            <a:spAutoFit/>
-          </a:bodyPr>
-          <a:lstStyle/>
-          <a:p>
-            <a:pPr algn="l">
-              <a:spcBef>
-                <a:spcPts val="0"/>
-              </a:spcBef>
-              <a:spcAft>
-                <a:spcPts val="0"/>
-              </a:spcAft>
-            </a:pPr>
-            <a:r>
-              <a:rPr sz="1200" b="1">
-                <a:solidFill>
-                  <a:srgbClr val="16335C"/>
-                </a:solidFill>
-                <a:latin typeface="Calibri"/>
-              </a:rPr>
-              <a:t>Captures leads + builds its own SEO</a:t>
-            </a:r>
-          </a:p>
-        </p:txBody>
-      </p:sp>
-      <p:sp>
-        <p:nvSpPr>
-          <p:cNvPr id="30" name="Rectangle 29"/>
+            <a:pPr algn="ctr">
+              <a:spcBef>
+                <a:spcPts val="0"/>
+              </a:spcBef>
+              <a:spcAft>
+                <a:spcPts val="0"/>
+              </a:spcAft>
+            </a:pPr>
+            <a:r>
+              <a:rPr sz="2600" b="1">
+                <a:solidFill>
+                  <a:srgbClr val="FFFFFF"/>
+                </a:solidFill>
+                <a:latin typeface="Calibri"/>
+              </a:rPr>
+              <a:t>5</a:t>
+            </a:r>
+          </a:p>
+        </p:txBody>
+      </p:sp>
+      <p:sp>
+        <p:nvSpPr>
+          <p:cNvPr id="24" name="Rectangle 23"/>
           <p:cNvSpPr/>
           <p:nvPr/>
         </p:nvSpPr>
         <p:spPr>
           <a:xfrm>
-            <a:off x="548640" y="4663440"/>
-            <a:ext cx="5486400" cy="512064"/>
+            <a:off x="1325880" y="5303520"/>
+            <a:ext cx="10287000" cy="777240"/>
           </a:xfrm>
           <a:prstGeom prst="rect">
             <a:avLst/>
@@ -8062,58 +8009,14 @@
       </p:sp>
       <p:sp>
         <p:nvSpPr>
-          <p:cNvPr id="31" name="Rectangle 30"/>
-          <p:cNvSpPr/>
-          <p:nvPr/>
-        </p:nvSpPr>
-        <p:spPr>
-          <a:xfrm>
-            <a:off x="6126480" y="4663440"/>
-            <a:ext cx="5486400" cy="512064"/>
-          </a:xfrm>
-          <a:prstGeom prst="rect">
-            <a:avLst/>
-          </a:prstGeom>
-          <a:solidFill>
-            <a:srgbClr val="F4F6F8"/>
-          </a:solidFill>
-          <a:ln>
-            <a:noFill/>
-          </a:ln>
-          <a:effectLst/>
-        </p:spPr>
-        <p:style>
-          <a:lnRef idx="1">
-            <a:schemeClr val="accent1"/>
-          </a:lnRef>
-          <a:fillRef idx="3">
-            <a:schemeClr val="accent1"/>
-          </a:fillRef>
-          <a:effectRef idx="2">
-            <a:schemeClr val="accent1"/>
-          </a:effectRef>
-          <a:fontRef idx="minor">
-            <a:schemeClr val="lt1"/>
-          </a:fontRef>
-        </p:style>
-        <p:txBody>
-          <a:bodyPr rtlCol="0" anchor="ctr"/>
-          <a:lstStyle/>
-          <a:p>
-            <a:pPr algn="ctr"/>
-          </a:p>
-        </p:txBody>
-      </p:sp>
-      <p:sp>
-        <p:nvSpPr>
-          <p:cNvPr id="32" name="TextBox 31"/>
+          <p:cNvPr id="25" name="TextBox 24"/>
           <p:cNvSpPr txBox="1"/>
           <p:nvPr/>
         </p:nvSpPr>
         <p:spPr>
           <a:xfrm>
-            <a:off x="731520" y="4663440"/>
-            <a:ext cx="5212080" cy="512064"/>
+            <a:off x="1554480" y="5376672"/>
+            <a:ext cx="9875520" cy="685800"/>
           </a:xfrm>
           <a:prstGeom prst="rect">
             <a:avLst/>
@@ -8131,410 +8034,43 @@
                 <a:spcPts val="0"/>
               </a:spcBef>
               <a:spcAft>
-                <a:spcPts val="0"/>
-              </a:spcAft>
-            </a:pPr>
-            <a:r>
-              <a:rPr sz="1200" b="0">
+                <a:spcPts val="200"/>
+              </a:spcAft>
+            </a:pPr>
+            <a:r>
+              <a:rPr sz="1600" b="1">
+                <a:solidFill>
+                  <a:srgbClr val="0B0B0C"/>
+                </a:solidFill>
+                <a:latin typeface="Calibri"/>
+              </a:rPr>
+              <a:t>Reconnect live product data</a:t>
+            </a:r>
+          </a:p>
+          <a:p>
+            <a:pPr algn="l">
+              <a:spcBef>
+                <a:spcPts val="0"/>
+              </a:spcBef>
+              <a:spcAft>
+                <a:spcPts val="0"/>
+              </a:spcAft>
+            </a:pPr>
+            <a:r>
+              <a:rPr sz="1250" b="0">
                 <a:solidFill>
                   <a:srgbClr val="5B626D"/>
                 </a:solidFill>
                 <a:latin typeface="Calibri"/>
               </a:rPr>
-              <a:t>No BIM / specifier capture</a:t>
-            </a:r>
-          </a:p>
-        </p:txBody>
-      </p:sp>
-      <p:sp>
-        <p:nvSpPr>
-          <p:cNvPr id="33" name="TextBox 32"/>
-          <p:cNvSpPr txBox="1"/>
-          <p:nvPr/>
-        </p:nvSpPr>
-        <p:spPr>
-          <a:xfrm>
-            <a:off x="6309360" y="4663440"/>
-            <a:ext cx="5212080" cy="512064"/>
-          </a:xfrm>
-          <a:prstGeom prst="rect">
-            <a:avLst/>
-          </a:prstGeom>
-          <a:noFill/>
-        </p:spPr>
-        <p:txBody>
-          <a:bodyPr wrap="square" anchor="ctr">
-            <a:spAutoFit/>
-          </a:bodyPr>
-          <a:lstStyle/>
-          <a:p>
-            <a:pPr algn="l">
-              <a:spcBef>
-                <a:spcPts val="0"/>
-              </a:spcBef>
-              <a:spcAft>
-                <a:spcPts val="0"/>
-              </a:spcAft>
-            </a:pPr>
-            <a:r>
-              <a:rPr sz="1200" b="1">
-                <a:solidFill>
-                  <a:srgbClr val="16335C"/>
-                </a:solidFill>
-                <a:latin typeface="Calibri"/>
-              </a:rPr>
-              <a:t>"Download BIM file" sends marketing a warm lead</a:t>
-            </a:r>
-          </a:p>
-        </p:txBody>
-      </p:sp>
-      <p:sp>
-        <p:nvSpPr>
-          <p:cNvPr id="34" name="Rectangle 33"/>
-          <p:cNvSpPr/>
-          <p:nvPr/>
-        </p:nvSpPr>
-        <p:spPr>
-          <a:xfrm>
-            <a:off x="548640" y="5212080"/>
-            <a:ext cx="5486400" cy="512064"/>
-          </a:xfrm>
-          <a:prstGeom prst="rect">
-            <a:avLst/>
-          </a:prstGeom>
-          <a:solidFill>
-            <a:srgbClr val="FFFFFF"/>
-          </a:solidFill>
-          <a:ln>
-            <a:noFill/>
-          </a:ln>
-          <a:effectLst/>
-        </p:spPr>
-        <p:style>
-          <a:lnRef idx="1">
-            <a:schemeClr val="accent1"/>
-          </a:lnRef>
-          <a:fillRef idx="3">
-            <a:schemeClr val="accent1"/>
-          </a:fillRef>
-          <a:effectRef idx="2">
-            <a:schemeClr val="accent1"/>
-          </a:effectRef>
-          <a:fontRef idx="minor">
-            <a:schemeClr val="lt1"/>
-          </a:fontRef>
-        </p:style>
-        <p:txBody>
-          <a:bodyPr rtlCol="0" anchor="ctr"/>
-          <a:lstStyle/>
-          <a:p>
-            <a:pPr algn="ctr"/>
-          </a:p>
-        </p:txBody>
-      </p:sp>
-      <p:sp>
-        <p:nvSpPr>
-          <p:cNvPr id="35" name="Rectangle 34"/>
-          <p:cNvSpPr/>
-          <p:nvPr/>
-        </p:nvSpPr>
-        <p:spPr>
-          <a:xfrm>
-            <a:off x="6126480" y="5212080"/>
-            <a:ext cx="5486400" cy="512064"/>
-          </a:xfrm>
-          <a:prstGeom prst="rect">
-            <a:avLst/>
-          </a:prstGeom>
-          <a:solidFill>
-            <a:srgbClr val="FFFFFF"/>
-          </a:solidFill>
-          <a:ln>
-            <a:noFill/>
-          </a:ln>
-          <a:effectLst/>
-        </p:spPr>
-        <p:style>
-          <a:lnRef idx="1">
-            <a:schemeClr val="accent1"/>
-          </a:lnRef>
-          <a:fillRef idx="3">
-            <a:schemeClr val="accent1"/>
-          </a:fillRef>
-          <a:effectRef idx="2">
-            <a:schemeClr val="accent1"/>
-          </a:effectRef>
-          <a:fontRef idx="minor">
-            <a:schemeClr val="lt1"/>
-          </a:fontRef>
-        </p:style>
-        <p:txBody>
-          <a:bodyPr rtlCol="0" anchor="ctr"/>
-          <a:lstStyle/>
-          <a:p>
-            <a:pPr algn="ctr"/>
-          </a:p>
-        </p:txBody>
-      </p:sp>
-      <p:sp>
-        <p:nvSpPr>
-          <p:cNvPr id="36" name="TextBox 35"/>
-          <p:cNvSpPr txBox="1"/>
-          <p:nvPr/>
-        </p:nvSpPr>
-        <p:spPr>
-          <a:xfrm>
-            <a:off x="731520" y="5212080"/>
-            <a:ext cx="5212080" cy="512064"/>
-          </a:xfrm>
-          <a:prstGeom prst="rect">
-            <a:avLst/>
-          </a:prstGeom>
-          <a:noFill/>
-        </p:spPr>
-        <p:txBody>
-          <a:bodyPr wrap="square" anchor="ctr">
-            <a:spAutoFit/>
-          </a:bodyPr>
-          <a:lstStyle/>
-          <a:p>
-            <a:pPr algn="l">
-              <a:spcBef>
-                <a:spcPts val="0"/>
-              </a:spcBef>
-              <a:spcAft>
-                <a:spcPts val="0"/>
-              </a:spcAft>
-            </a:pPr>
-            <a:r>
-              <a:rPr sz="1200" b="0">
-                <a:solidFill>
-                  <a:srgbClr val="5B626D"/>
-                </a:solidFill>
-                <a:latin typeface="Calibri"/>
-              </a:rPr>
-              <a:t>Bespoke quotes = lots of back-and-forth</a:t>
-            </a:r>
-          </a:p>
-        </p:txBody>
-      </p:sp>
-      <p:sp>
-        <p:nvSpPr>
-          <p:cNvPr id="37" name="TextBox 36"/>
-          <p:cNvSpPr txBox="1"/>
-          <p:nvPr/>
-        </p:nvSpPr>
-        <p:spPr>
-          <a:xfrm>
-            <a:off x="6309360" y="5212080"/>
-            <a:ext cx="5212080" cy="512064"/>
-          </a:xfrm>
-          <a:prstGeom prst="rect">
-            <a:avLst/>
-          </a:prstGeom>
-          <a:noFill/>
-        </p:spPr>
-        <p:txBody>
-          <a:bodyPr wrap="square" anchor="ctr">
-            <a:spAutoFit/>
-          </a:bodyPr>
-          <a:lstStyle/>
-          <a:p>
-            <a:pPr algn="l">
-              <a:spcBef>
-                <a:spcPts val="0"/>
-              </a:spcBef>
-              <a:spcAft>
-                <a:spcPts val="0"/>
-              </a:spcAft>
-            </a:pPr>
-            <a:r>
-              <a:rPr sz="1200" b="1">
-                <a:solidFill>
-                  <a:srgbClr val="16335C"/>
-                </a:solidFill>
-                <a:latin typeface="Calibri"/>
-              </a:rPr>
-              <a:t>Flow+ Designer = ready-to-quote scheme</a:t>
-            </a:r>
-          </a:p>
-        </p:txBody>
-      </p:sp>
-      <p:sp>
-        <p:nvSpPr>
-          <p:cNvPr id="38" name="Rectangle 37"/>
-          <p:cNvSpPr/>
-          <p:nvPr/>
-        </p:nvSpPr>
-        <p:spPr>
-          <a:xfrm>
-            <a:off x="548640" y="5760720"/>
-            <a:ext cx="5486400" cy="512064"/>
-          </a:xfrm>
-          <a:prstGeom prst="rect">
-            <a:avLst/>
-          </a:prstGeom>
-          <a:solidFill>
-            <a:srgbClr val="F4F6F8"/>
-          </a:solidFill>
-          <a:ln>
-            <a:noFill/>
-          </a:ln>
-          <a:effectLst/>
-        </p:spPr>
-        <p:style>
-          <a:lnRef idx="1">
-            <a:schemeClr val="accent1"/>
-          </a:lnRef>
-          <a:fillRef idx="3">
-            <a:schemeClr val="accent1"/>
-          </a:fillRef>
-          <a:effectRef idx="2">
-            <a:schemeClr val="accent1"/>
-          </a:effectRef>
-          <a:fontRef idx="minor">
-            <a:schemeClr val="lt1"/>
-          </a:fontRef>
-        </p:style>
-        <p:txBody>
-          <a:bodyPr rtlCol="0" anchor="ctr"/>
-          <a:lstStyle/>
-          <a:p>
-            <a:pPr algn="ctr"/>
-          </a:p>
-        </p:txBody>
-      </p:sp>
-      <p:sp>
-        <p:nvSpPr>
-          <p:cNvPr id="39" name="Rectangle 38"/>
-          <p:cNvSpPr/>
-          <p:nvPr/>
-        </p:nvSpPr>
-        <p:spPr>
-          <a:xfrm>
-            <a:off x="6126480" y="5760720"/>
-            <a:ext cx="5486400" cy="512064"/>
-          </a:xfrm>
-          <a:prstGeom prst="rect">
-            <a:avLst/>
-          </a:prstGeom>
-          <a:solidFill>
-            <a:srgbClr val="F4F6F8"/>
-          </a:solidFill>
-          <a:ln>
-            <a:noFill/>
-          </a:ln>
-          <a:effectLst/>
-        </p:spPr>
-        <p:style>
-          <a:lnRef idx="1">
-            <a:schemeClr val="accent1"/>
-          </a:lnRef>
-          <a:fillRef idx="3">
-            <a:schemeClr val="accent1"/>
-          </a:fillRef>
-          <a:effectRef idx="2">
-            <a:schemeClr val="accent1"/>
-          </a:effectRef>
-          <a:fontRef idx="minor">
-            <a:schemeClr val="lt1"/>
-          </a:fontRef>
-        </p:style>
-        <p:txBody>
-          <a:bodyPr rtlCol="0" anchor="ctr"/>
-          <a:lstStyle/>
-          <a:p>
-            <a:pPr algn="ctr"/>
-          </a:p>
-        </p:txBody>
-      </p:sp>
-      <p:sp>
-        <p:nvSpPr>
-          <p:cNvPr id="40" name="TextBox 39"/>
-          <p:cNvSpPr txBox="1"/>
-          <p:nvPr/>
-        </p:nvSpPr>
-        <p:spPr>
-          <a:xfrm>
-            <a:off x="731520" y="5760720"/>
-            <a:ext cx="5212080" cy="512064"/>
-          </a:xfrm>
-          <a:prstGeom prst="rect">
-            <a:avLst/>
-          </a:prstGeom>
-          <a:noFill/>
-        </p:spPr>
-        <p:txBody>
-          <a:bodyPr wrap="square" anchor="ctr">
-            <a:spAutoFit/>
-          </a:bodyPr>
-          <a:lstStyle/>
-          <a:p>
-            <a:pPr algn="l">
-              <a:spcBef>
-                <a:spcPts val="0"/>
-              </a:spcBef>
-              <a:spcAft>
-                <a:spcPts val="0"/>
-              </a:spcAft>
-            </a:pPr>
-            <a:r>
-              <a:rPr sz="1200" b="0">
-                <a:solidFill>
-                  <a:srgbClr val="5B626D"/>
-                </a:solidFill>
-                <a:latin typeface="Calibri"/>
-              </a:rPr>
-              <a:t>Slower, page-builder overhead</a:t>
-            </a:r>
-          </a:p>
-        </p:txBody>
-      </p:sp>
-      <p:sp>
-        <p:nvSpPr>
-          <p:cNvPr id="41" name="TextBox 40"/>
-          <p:cNvSpPr txBox="1"/>
-          <p:nvPr/>
-        </p:nvSpPr>
-        <p:spPr>
-          <a:xfrm>
-            <a:off x="6309360" y="5760720"/>
-            <a:ext cx="5212080" cy="512064"/>
-          </a:xfrm>
-          <a:prstGeom prst="rect">
-            <a:avLst/>
-          </a:prstGeom>
-          <a:noFill/>
-        </p:spPr>
-        <p:txBody>
-          <a:bodyPr wrap="square" anchor="ctr">
-            <a:spAutoFit/>
-          </a:bodyPr>
-          <a:lstStyle/>
-          <a:p>
-            <a:pPr algn="l">
-              <a:spcBef>
-                <a:spcPts val="0"/>
-              </a:spcBef>
-              <a:spcAft>
-                <a:spcPts val="0"/>
-              </a:spcAft>
-            </a:pPr>
-            <a:r>
-              <a:rPr sz="1200" b="1">
-                <a:solidFill>
-                  <a:srgbClr val="16335C"/>
-                </a:solidFill>
-                <a:latin typeface="Calibri"/>
-              </a:rPr>
-              <a:t>Fast, modern, search-friendly</a:t>
-            </a:r>
-          </a:p>
-        </p:txBody>
-      </p:sp>
-      <p:sp>
-        <p:nvSpPr>
-          <p:cNvPr id="42" name="TextBox 41"/>
+              <a:t>Final step, switched on last</a:t>
+            </a:r>
+          </a:p>
+        </p:txBody>
+      </p:sp>
+      <p:sp>
+        <p:nvSpPr>
+          <p:cNvPr id="26" name="TextBox 25"/>
           <p:cNvSpPr txBox="1"/>
           <p:nvPr/>
         </p:nvSpPr>
@@ -8576,7 +8112,7 @@
       </p:sp>
       <p:sp>
         <p:nvSpPr>
-          <p:cNvPr id="43" name="TextBox 42"/>
+          <p:cNvPr id="27" name="TextBox 26"/>
           <p:cNvSpPr txBox="1"/>
           <p:nvPr/>
         </p:nvSpPr>
@@ -8611,7 +8147,7 @@
                 </a:solidFill>
                 <a:latin typeface="Calibri"/>
               </a:rPr>
-              <a:t>11</a:t>
+              <a:t>12</a:t>
             </a:r>
           </a:p>
         </p:txBody>
@@ -8625,6 +8161,1849 @@
 </file>
 
 <file path=ppt/slides/slide13.xml><?xml version="1.0" encoding="utf-8"?>
+<p:sld xmlns:a="http://schemas.openxmlformats.org/drawingml/2006/main" xmlns:p="http://schemas.openxmlformats.org/presentationml/2006/main" xmlns:r="http://schemas.openxmlformats.org/officeDocument/2006/relationships">
+  <p:cSld>
+    <p:spTree>
+      <p:nvGrpSpPr>
+        <p:cNvPr id="1" name=""/>
+        <p:cNvGrpSpPr/>
+        <p:nvPr/>
+      </p:nvGrpSpPr>
+      <p:grpSpPr/>
+      <p:sp>
+        <p:nvSpPr>
+          <p:cNvPr id="2" name="Rectangle 1"/>
+          <p:cNvSpPr/>
+          <p:nvPr/>
+        </p:nvSpPr>
+        <p:spPr>
+          <a:xfrm>
+            <a:off x="0" y="0"/>
+            <a:ext cx="12191695" cy="1234440"/>
+          </a:xfrm>
+          <a:prstGeom prst="rect">
+            <a:avLst/>
+          </a:prstGeom>
+          <a:solidFill>
+            <a:srgbClr val="FFFFFF"/>
+          </a:solidFill>
+          <a:ln>
+            <a:noFill/>
+          </a:ln>
+          <a:effectLst/>
+        </p:spPr>
+        <p:style>
+          <a:lnRef idx="1">
+            <a:schemeClr val="accent1"/>
+          </a:lnRef>
+          <a:fillRef idx="3">
+            <a:schemeClr val="accent1"/>
+          </a:fillRef>
+          <a:effectRef idx="2">
+            <a:schemeClr val="accent1"/>
+          </a:effectRef>
+          <a:fontRef idx="minor">
+            <a:schemeClr val="lt1"/>
+          </a:fontRef>
+        </p:style>
+        <p:txBody>
+          <a:bodyPr rtlCol="0" anchor="ctr"/>
+          <a:lstStyle/>
+          <a:p>
+            <a:pPr algn="ctr"/>
+          </a:p>
+        </p:txBody>
+      </p:sp>
+      <p:sp>
+        <p:nvSpPr>
+          <p:cNvPr id="3" name="Rectangle 2"/>
+          <p:cNvSpPr/>
+          <p:nvPr/>
+        </p:nvSpPr>
+        <p:spPr>
+          <a:xfrm>
+            <a:off x="0" y="0"/>
+            <a:ext cx="201168" cy="1234440"/>
+          </a:xfrm>
+          <a:prstGeom prst="rect">
+            <a:avLst/>
+          </a:prstGeom>
+          <a:solidFill>
+            <a:srgbClr val="1D4ED8"/>
+          </a:solidFill>
+          <a:ln>
+            <a:noFill/>
+          </a:ln>
+          <a:effectLst/>
+        </p:spPr>
+        <p:style>
+          <a:lnRef idx="1">
+            <a:schemeClr val="accent1"/>
+          </a:lnRef>
+          <a:fillRef idx="3">
+            <a:schemeClr val="accent1"/>
+          </a:fillRef>
+          <a:effectRef idx="2">
+            <a:schemeClr val="accent1"/>
+          </a:effectRef>
+          <a:fontRef idx="minor">
+            <a:schemeClr val="lt1"/>
+          </a:fontRef>
+        </p:style>
+        <p:txBody>
+          <a:bodyPr rtlCol="0" anchor="ctr"/>
+          <a:lstStyle/>
+          <a:p>
+            <a:pPr algn="ctr"/>
+          </a:p>
+        </p:txBody>
+      </p:sp>
+      <p:sp>
+        <p:nvSpPr>
+          <p:cNvPr id="4" name="TextBox 3"/>
+          <p:cNvSpPr txBox="1"/>
+          <p:nvPr/>
+        </p:nvSpPr>
+        <p:spPr>
+          <a:xfrm>
+            <a:off x="548640" y="164592"/>
+            <a:ext cx="10972800" cy="1005840"/>
+          </a:xfrm>
+          <a:prstGeom prst="rect">
+            <a:avLst/>
+          </a:prstGeom>
+          <a:noFill/>
+        </p:spPr>
+        <p:txBody>
+          <a:bodyPr wrap="square" anchor="t">
+            <a:spAutoFit/>
+          </a:bodyPr>
+          <a:lstStyle/>
+          <a:p>
+            <a:pPr algn="l">
+              <a:spcBef>
+                <a:spcPts val="0"/>
+              </a:spcBef>
+              <a:spcAft>
+                <a:spcPts val="200"/>
+              </a:spcAft>
+            </a:pPr>
+            <a:r>
+              <a:rPr sz="1300" b="1">
+                <a:solidFill>
+                  <a:srgbClr val="1D4ED8"/>
+                </a:solidFill>
+                <a:latin typeface="Calibri"/>
+              </a:rPr>
+              <a:t>THE BOTTOM LINE</a:t>
+            </a:r>
+          </a:p>
+          <a:p>
+            <a:pPr algn="l">
+              <a:spcBef>
+                <a:spcPts val="0"/>
+              </a:spcBef>
+              <a:spcAft>
+                <a:spcPts val="0"/>
+              </a:spcAft>
+            </a:pPr>
+            <a:r>
+              <a:rPr sz="2800" b="1">
+                <a:solidFill>
+                  <a:srgbClr val="0B0B0C"/>
+                </a:solidFill>
+                <a:latin typeface="Calibri"/>
+              </a:rPr>
+              <a:t>Old site vs new site</a:t>
+            </a:r>
+          </a:p>
+        </p:txBody>
+      </p:sp>
+      <p:sp>
+        <p:nvSpPr>
+          <p:cNvPr id="5" name="Rectangle 4"/>
+          <p:cNvSpPr/>
+          <p:nvPr/>
+        </p:nvSpPr>
+        <p:spPr>
+          <a:xfrm>
+            <a:off x="548640" y="1097280"/>
+            <a:ext cx="11064240" cy="25400"/>
+          </a:xfrm>
+          <a:prstGeom prst="rect">
+            <a:avLst/>
+          </a:prstGeom>
+          <a:solidFill>
+            <a:srgbClr val="F4F6F8"/>
+          </a:solidFill>
+          <a:ln>
+            <a:noFill/>
+          </a:ln>
+          <a:effectLst/>
+        </p:spPr>
+        <p:style>
+          <a:lnRef idx="1">
+            <a:schemeClr val="accent1"/>
+          </a:lnRef>
+          <a:fillRef idx="3">
+            <a:schemeClr val="accent1"/>
+          </a:fillRef>
+          <a:effectRef idx="2">
+            <a:schemeClr val="accent1"/>
+          </a:effectRef>
+          <a:fontRef idx="minor">
+            <a:schemeClr val="lt1"/>
+          </a:fontRef>
+        </p:style>
+        <p:txBody>
+          <a:bodyPr rtlCol="0" anchor="ctr"/>
+          <a:lstStyle/>
+          <a:p>
+            <a:pPr algn="ctr"/>
+          </a:p>
+        </p:txBody>
+      </p:sp>
+      <p:sp>
+        <p:nvSpPr>
+          <p:cNvPr id="6" name="Rectangle 5"/>
+          <p:cNvSpPr/>
+          <p:nvPr/>
+        </p:nvSpPr>
+        <p:spPr>
+          <a:xfrm>
+            <a:off x="548640" y="1417320"/>
+            <a:ext cx="5486400" cy="457200"/>
+          </a:xfrm>
+          <a:prstGeom prst="rect">
+            <a:avLst/>
+          </a:prstGeom>
+          <a:solidFill>
+            <a:srgbClr val="0B0B0C"/>
+          </a:solidFill>
+          <a:ln>
+            <a:noFill/>
+          </a:ln>
+          <a:effectLst/>
+        </p:spPr>
+        <p:style>
+          <a:lnRef idx="1">
+            <a:schemeClr val="accent1"/>
+          </a:lnRef>
+          <a:fillRef idx="3">
+            <a:schemeClr val="accent1"/>
+          </a:fillRef>
+          <a:effectRef idx="2">
+            <a:schemeClr val="accent1"/>
+          </a:effectRef>
+          <a:fontRef idx="minor">
+            <a:schemeClr val="lt1"/>
+          </a:fontRef>
+        </p:style>
+        <p:txBody>
+          <a:bodyPr rtlCol="0" anchor="ctr"/>
+          <a:lstStyle/>
+          <a:p>
+            <a:pPr algn="ctr"/>
+          </a:p>
+        </p:txBody>
+      </p:sp>
+      <p:sp>
+        <p:nvSpPr>
+          <p:cNvPr id="7" name="Rectangle 6"/>
+          <p:cNvSpPr/>
+          <p:nvPr/>
+        </p:nvSpPr>
+        <p:spPr>
+          <a:xfrm>
+            <a:off x="6126480" y="1417320"/>
+            <a:ext cx="5486400" cy="457200"/>
+          </a:xfrm>
+          <a:prstGeom prst="rect">
+            <a:avLst/>
+          </a:prstGeom>
+          <a:solidFill>
+            <a:srgbClr val="1D4ED8"/>
+          </a:solidFill>
+          <a:ln>
+            <a:noFill/>
+          </a:ln>
+          <a:effectLst/>
+        </p:spPr>
+        <p:style>
+          <a:lnRef idx="1">
+            <a:schemeClr val="accent1"/>
+          </a:lnRef>
+          <a:fillRef idx="3">
+            <a:schemeClr val="accent1"/>
+          </a:fillRef>
+          <a:effectRef idx="2">
+            <a:schemeClr val="accent1"/>
+          </a:effectRef>
+          <a:fontRef idx="minor">
+            <a:schemeClr val="lt1"/>
+          </a:fontRef>
+        </p:style>
+        <p:txBody>
+          <a:bodyPr rtlCol="0" anchor="ctr"/>
+          <a:lstStyle/>
+          <a:p>
+            <a:pPr algn="ctr"/>
+          </a:p>
+        </p:txBody>
+      </p:sp>
+      <p:sp>
+        <p:nvSpPr>
+          <p:cNvPr id="8" name="TextBox 7"/>
+          <p:cNvSpPr txBox="1"/>
+          <p:nvPr/>
+        </p:nvSpPr>
+        <p:spPr>
+          <a:xfrm>
+            <a:off x="731520" y="1417320"/>
+            <a:ext cx="5120640" cy="457200"/>
+          </a:xfrm>
+          <a:prstGeom prst="rect">
+            <a:avLst/>
+          </a:prstGeom>
+          <a:noFill/>
+        </p:spPr>
+        <p:txBody>
+          <a:bodyPr wrap="square" anchor="ctr">
+            <a:spAutoFit/>
+          </a:bodyPr>
+          <a:lstStyle/>
+          <a:p>
+            <a:pPr algn="l">
+              <a:spcBef>
+                <a:spcPts val="0"/>
+              </a:spcBef>
+              <a:spcAft>
+                <a:spcPts val="0"/>
+              </a:spcAft>
+            </a:pPr>
+            <a:r>
+              <a:rPr sz="1300" b="1">
+                <a:solidFill>
+                  <a:srgbClr val="FFFFFF"/>
+                </a:solidFill>
+                <a:latin typeface="Calibri"/>
+              </a:rPr>
+              <a:t>OLD SITE</a:t>
+            </a:r>
+          </a:p>
+        </p:txBody>
+      </p:sp>
+      <p:sp>
+        <p:nvSpPr>
+          <p:cNvPr id="9" name="TextBox 8"/>
+          <p:cNvSpPr txBox="1"/>
+          <p:nvPr/>
+        </p:nvSpPr>
+        <p:spPr>
+          <a:xfrm>
+            <a:off x="6309360" y="1417320"/>
+            <a:ext cx="5120640" cy="457200"/>
+          </a:xfrm>
+          <a:prstGeom prst="rect">
+            <a:avLst/>
+          </a:prstGeom>
+          <a:noFill/>
+        </p:spPr>
+        <p:txBody>
+          <a:bodyPr wrap="square" anchor="ctr">
+            <a:spAutoFit/>
+          </a:bodyPr>
+          <a:lstStyle/>
+          <a:p>
+            <a:pPr algn="l">
+              <a:spcBef>
+                <a:spcPts val="0"/>
+              </a:spcBef>
+              <a:spcAft>
+                <a:spcPts val="0"/>
+              </a:spcAft>
+            </a:pPr>
+            <a:r>
+              <a:rPr sz="1300" b="1">
+                <a:solidFill>
+                  <a:srgbClr val="FFFFFF"/>
+                </a:solidFill>
+                <a:latin typeface="Calibri"/>
+              </a:rPr>
+              <a:t>NEW SITE</a:t>
+            </a:r>
+          </a:p>
+        </p:txBody>
+      </p:sp>
+      <p:sp>
+        <p:nvSpPr>
+          <p:cNvPr id="10" name="Rectangle 9"/>
+          <p:cNvSpPr/>
+          <p:nvPr/>
+        </p:nvSpPr>
+        <p:spPr>
+          <a:xfrm>
+            <a:off x="548640" y="1920240"/>
+            <a:ext cx="5486400" cy="512064"/>
+          </a:xfrm>
+          <a:prstGeom prst="rect">
+            <a:avLst/>
+          </a:prstGeom>
+          <a:solidFill>
+            <a:srgbClr val="FFFFFF"/>
+          </a:solidFill>
+          <a:ln>
+            <a:noFill/>
+          </a:ln>
+          <a:effectLst/>
+        </p:spPr>
+        <p:style>
+          <a:lnRef idx="1">
+            <a:schemeClr val="accent1"/>
+          </a:lnRef>
+          <a:fillRef idx="3">
+            <a:schemeClr val="accent1"/>
+          </a:fillRef>
+          <a:effectRef idx="2">
+            <a:schemeClr val="accent1"/>
+          </a:effectRef>
+          <a:fontRef idx="minor">
+            <a:schemeClr val="lt1"/>
+          </a:fontRef>
+        </p:style>
+        <p:txBody>
+          <a:bodyPr rtlCol="0" anchor="ctr"/>
+          <a:lstStyle/>
+          <a:p>
+            <a:pPr algn="ctr"/>
+          </a:p>
+        </p:txBody>
+      </p:sp>
+      <p:sp>
+        <p:nvSpPr>
+          <p:cNvPr id="11" name="Rectangle 10"/>
+          <p:cNvSpPr/>
+          <p:nvPr/>
+        </p:nvSpPr>
+        <p:spPr>
+          <a:xfrm>
+            <a:off x="6126480" y="1920240"/>
+            <a:ext cx="5486400" cy="512064"/>
+          </a:xfrm>
+          <a:prstGeom prst="rect">
+            <a:avLst/>
+          </a:prstGeom>
+          <a:solidFill>
+            <a:srgbClr val="FFFFFF"/>
+          </a:solidFill>
+          <a:ln>
+            <a:noFill/>
+          </a:ln>
+          <a:effectLst/>
+        </p:spPr>
+        <p:style>
+          <a:lnRef idx="1">
+            <a:schemeClr val="accent1"/>
+          </a:lnRef>
+          <a:fillRef idx="3">
+            <a:schemeClr val="accent1"/>
+          </a:fillRef>
+          <a:effectRef idx="2">
+            <a:schemeClr val="accent1"/>
+          </a:effectRef>
+          <a:fontRef idx="minor">
+            <a:schemeClr val="lt1"/>
+          </a:fontRef>
+        </p:style>
+        <p:txBody>
+          <a:bodyPr rtlCol="0" anchor="ctr"/>
+          <a:lstStyle/>
+          <a:p>
+            <a:pPr algn="ctr"/>
+          </a:p>
+        </p:txBody>
+      </p:sp>
+      <p:sp>
+        <p:nvSpPr>
+          <p:cNvPr id="12" name="TextBox 11"/>
+          <p:cNvSpPr txBox="1"/>
+          <p:nvPr/>
+        </p:nvSpPr>
+        <p:spPr>
+          <a:xfrm>
+            <a:off x="731520" y="1920240"/>
+            <a:ext cx="5212080" cy="512064"/>
+          </a:xfrm>
+          <a:prstGeom prst="rect">
+            <a:avLst/>
+          </a:prstGeom>
+          <a:noFill/>
+        </p:spPr>
+        <p:txBody>
+          <a:bodyPr wrap="square" anchor="ctr">
+            <a:spAutoFit/>
+          </a:bodyPr>
+          <a:lstStyle/>
+          <a:p>
+            <a:pPr algn="l">
+              <a:spcBef>
+                <a:spcPts val="0"/>
+              </a:spcBef>
+              <a:spcAft>
+                <a:spcPts val="0"/>
+              </a:spcAft>
+            </a:pPr>
+            <a:r>
+              <a:rPr sz="1200" b="0">
+                <a:solidFill>
+                  <a:srgbClr val="5B626D"/>
+                </a:solidFill>
+                <a:latin typeface="Calibri"/>
+              </a:rPr>
+              <a:t>248 GB of bloat, 91% duplicate images</a:t>
+            </a:r>
+          </a:p>
+        </p:txBody>
+      </p:sp>
+      <p:sp>
+        <p:nvSpPr>
+          <p:cNvPr id="13" name="TextBox 12"/>
+          <p:cNvSpPr txBox="1"/>
+          <p:nvPr/>
+        </p:nvSpPr>
+        <p:spPr>
+          <a:xfrm>
+            <a:off x="6309360" y="1920240"/>
+            <a:ext cx="5212080" cy="512064"/>
+          </a:xfrm>
+          <a:prstGeom prst="rect">
+            <a:avLst/>
+          </a:prstGeom>
+          <a:noFill/>
+        </p:spPr>
+        <p:txBody>
+          <a:bodyPr wrap="square" anchor="ctr">
+            <a:spAutoFit/>
+          </a:bodyPr>
+          <a:lstStyle/>
+          <a:p>
+            <a:pPr algn="l">
+              <a:spcBef>
+                <a:spcPts val="0"/>
+              </a:spcBef>
+              <a:spcAft>
+                <a:spcPts val="0"/>
+              </a:spcAft>
+            </a:pPr>
+            <a:r>
+              <a:rPr sz="1200" b="1">
+                <a:solidFill>
+                  <a:srgbClr val="16335C"/>
+                </a:solidFill>
+                <a:latin typeface="Calibri"/>
+              </a:rPr>
+              <a:t>Cleaned up, lean media library</a:t>
+            </a:r>
+          </a:p>
+        </p:txBody>
+      </p:sp>
+      <p:sp>
+        <p:nvSpPr>
+          <p:cNvPr id="14" name="Rectangle 13"/>
+          <p:cNvSpPr/>
+          <p:nvPr/>
+        </p:nvSpPr>
+        <p:spPr>
+          <a:xfrm>
+            <a:off x="548640" y="2468880"/>
+            <a:ext cx="5486400" cy="512064"/>
+          </a:xfrm>
+          <a:prstGeom prst="rect">
+            <a:avLst/>
+          </a:prstGeom>
+          <a:solidFill>
+            <a:srgbClr val="F4F6F8"/>
+          </a:solidFill>
+          <a:ln>
+            <a:noFill/>
+          </a:ln>
+          <a:effectLst/>
+        </p:spPr>
+        <p:style>
+          <a:lnRef idx="1">
+            <a:schemeClr val="accent1"/>
+          </a:lnRef>
+          <a:fillRef idx="3">
+            <a:schemeClr val="accent1"/>
+          </a:fillRef>
+          <a:effectRef idx="2">
+            <a:schemeClr val="accent1"/>
+          </a:effectRef>
+          <a:fontRef idx="minor">
+            <a:schemeClr val="lt1"/>
+          </a:fontRef>
+        </p:style>
+        <p:txBody>
+          <a:bodyPr rtlCol="0" anchor="ctr"/>
+          <a:lstStyle/>
+          <a:p>
+            <a:pPr algn="ctr"/>
+          </a:p>
+        </p:txBody>
+      </p:sp>
+      <p:sp>
+        <p:nvSpPr>
+          <p:cNvPr id="15" name="Rectangle 14"/>
+          <p:cNvSpPr/>
+          <p:nvPr/>
+        </p:nvSpPr>
+        <p:spPr>
+          <a:xfrm>
+            <a:off x="6126480" y="2468880"/>
+            <a:ext cx="5486400" cy="512064"/>
+          </a:xfrm>
+          <a:prstGeom prst="rect">
+            <a:avLst/>
+          </a:prstGeom>
+          <a:solidFill>
+            <a:srgbClr val="F4F6F8"/>
+          </a:solidFill>
+          <a:ln>
+            <a:noFill/>
+          </a:ln>
+          <a:effectLst/>
+        </p:spPr>
+        <p:style>
+          <a:lnRef idx="1">
+            <a:schemeClr val="accent1"/>
+          </a:lnRef>
+          <a:fillRef idx="3">
+            <a:schemeClr val="accent1"/>
+          </a:fillRef>
+          <a:effectRef idx="2">
+            <a:schemeClr val="accent1"/>
+          </a:effectRef>
+          <a:fontRef idx="minor">
+            <a:schemeClr val="lt1"/>
+          </a:fontRef>
+        </p:style>
+        <p:txBody>
+          <a:bodyPr rtlCol="0" anchor="ctr"/>
+          <a:lstStyle/>
+          <a:p>
+            <a:pPr algn="ctr"/>
+          </a:p>
+        </p:txBody>
+      </p:sp>
+      <p:sp>
+        <p:nvSpPr>
+          <p:cNvPr id="16" name="TextBox 15"/>
+          <p:cNvSpPr txBox="1"/>
+          <p:nvPr/>
+        </p:nvSpPr>
+        <p:spPr>
+          <a:xfrm>
+            <a:off x="731520" y="2468880"/>
+            <a:ext cx="5212080" cy="512064"/>
+          </a:xfrm>
+          <a:prstGeom prst="rect">
+            <a:avLst/>
+          </a:prstGeom>
+          <a:noFill/>
+        </p:spPr>
+        <p:txBody>
+          <a:bodyPr wrap="square" anchor="ctr">
+            <a:spAutoFit/>
+          </a:bodyPr>
+          <a:lstStyle/>
+          <a:p>
+            <a:pPr algn="l">
+              <a:spcBef>
+                <a:spcPts val="0"/>
+              </a:spcBef>
+              <a:spcAft>
+                <a:spcPts val="0"/>
+              </a:spcAft>
+            </a:pPr>
+            <a:r>
+              <a:rPr sz="1200" b="0">
+                <a:solidFill>
+                  <a:srgbClr val="5B626D"/>
+                </a:solidFill>
+                <a:latin typeface="Calibri"/>
+              </a:rPr>
+              <a:t>Backups failing since ~Oct 2025</a:t>
+            </a:r>
+          </a:p>
+        </p:txBody>
+      </p:sp>
+      <p:sp>
+        <p:nvSpPr>
+          <p:cNvPr id="17" name="TextBox 16"/>
+          <p:cNvSpPr txBox="1"/>
+          <p:nvPr/>
+        </p:nvSpPr>
+        <p:spPr>
+          <a:xfrm>
+            <a:off x="6309360" y="2468880"/>
+            <a:ext cx="5212080" cy="512064"/>
+          </a:xfrm>
+          <a:prstGeom prst="rect">
+            <a:avLst/>
+          </a:prstGeom>
+          <a:noFill/>
+        </p:spPr>
+        <p:txBody>
+          <a:bodyPr wrap="square" anchor="ctr">
+            <a:spAutoFit/>
+          </a:bodyPr>
+          <a:lstStyle/>
+          <a:p>
+            <a:pPr algn="l">
+              <a:spcBef>
+                <a:spcPts val="0"/>
+              </a:spcBef>
+              <a:spcAft>
+                <a:spcPts val="0"/>
+              </a:spcAft>
+            </a:pPr>
+            <a:r>
+              <a:rPr sz="1200" b="1">
+                <a:solidFill>
+                  <a:srgbClr val="16335C"/>
+                </a:solidFill>
+                <a:latin typeface="Calibri"/>
+              </a:rPr>
+              <a:t>Reliable, fast backups</a:t>
+            </a:r>
+          </a:p>
+        </p:txBody>
+      </p:sp>
+      <p:sp>
+        <p:nvSpPr>
+          <p:cNvPr id="18" name="Rectangle 17"/>
+          <p:cNvSpPr/>
+          <p:nvPr/>
+        </p:nvSpPr>
+        <p:spPr>
+          <a:xfrm>
+            <a:off x="548640" y="3017520"/>
+            <a:ext cx="5486400" cy="512064"/>
+          </a:xfrm>
+          <a:prstGeom prst="rect">
+            <a:avLst/>
+          </a:prstGeom>
+          <a:solidFill>
+            <a:srgbClr val="FFFFFF"/>
+          </a:solidFill>
+          <a:ln>
+            <a:noFill/>
+          </a:ln>
+          <a:effectLst/>
+        </p:spPr>
+        <p:style>
+          <a:lnRef idx="1">
+            <a:schemeClr val="accent1"/>
+          </a:lnRef>
+          <a:fillRef idx="3">
+            <a:schemeClr val="accent1"/>
+          </a:fillRef>
+          <a:effectRef idx="2">
+            <a:schemeClr val="accent1"/>
+          </a:effectRef>
+          <a:fontRef idx="minor">
+            <a:schemeClr val="lt1"/>
+          </a:fontRef>
+        </p:style>
+        <p:txBody>
+          <a:bodyPr rtlCol="0" anchor="ctr"/>
+          <a:lstStyle/>
+          <a:p>
+            <a:pPr algn="ctr"/>
+          </a:p>
+        </p:txBody>
+      </p:sp>
+      <p:sp>
+        <p:nvSpPr>
+          <p:cNvPr id="19" name="Rectangle 18"/>
+          <p:cNvSpPr/>
+          <p:nvPr/>
+        </p:nvSpPr>
+        <p:spPr>
+          <a:xfrm>
+            <a:off x="6126480" y="3017520"/>
+            <a:ext cx="5486400" cy="512064"/>
+          </a:xfrm>
+          <a:prstGeom prst="rect">
+            <a:avLst/>
+          </a:prstGeom>
+          <a:solidFill>
+            <a:srgbClr val="FFFFFF"/>
+          </a:solidFill>
+          <a:ln>
+            <a:noFill/>
+          </a:ln>
+          <a:effectLst/>
+        </p:spPr>
+        <p:style>
+          <a:lnRef idx="1">
+            <a:schemeClr val="accent1"/>
+          </a:lnRef>
+          <a:fillRef idx="3">
+            <a:schemeClr val="accent1"/>
+          </a:fillRef>
+          <a:effectRef idx="2">
+            <a:schemeClr val="accent1"/>
+          </a:effectRef>
+          <a:fontRef idx="minor">
+            <a:schemeClr val="lt1"/>
+          </a:fontRef>
+        </p:style>
+        <p:txBody>
+          <a:bodyPr rtlCol="0" anchor="ctr"/>
+          <a:lstStyle/>
+          <a:p>
+            <a:pPr algn="ctr"/>
+          </a:p>
+        </p:txBody>
+      </p:sp>
+      <p:sp>
+        <p:nvSpPr>
+          <p:cNvPr id="20" name="TextBox 19"/>
+          <p:cNvSpPr txBox="1"/>
+          <p:nvPr/>
+        </p:nvSpPr>
+        <p:spPr>
+          <a:xfrm>
+            <a:off x="731520" y="3017520"/>
+            <a:ext cx="5212080" cy="512064"/>
+          </a:xfrm>
+          <a:prstGeom prst="rect">
+            <a:avLst/>
+          </a:prstGeom>
+          <a:noFill/>
+        </p:spPr>
+        <p:txBody>
+          <a:bodyPr wrap="square" anchor="ctr">
+            <a:spAutoFit/>
+          </a:bodyPr>
+          <a:lstStyle/>
+          <a:p>
+            <a:pPr algn="l">
+              <a:spcBef>
+                <a:spcPts val="0"/>
+              </a:spcBef>
+              <a:spcAft>
+                <a:spcPts val="0"/>
+              </a:spcAft>
+            </a:pPr>
+            <a:r>
+              <a:rPr sz="1200" b="0">
+                <a:solidFill>
+                  <a:srgbClr val="5B626D"/>
+                </a:solidFill>
+                <a:latin typeface="Calibri"/>
+              </a:rPr>
+              <a:t>Higher, growing hosting cost</a:t>
+            </a:r>
+          </a:p>
+        </p:txBody>
+      </p:sp>
+      <p:sp>
+        <p:nvSpPr>
+          <p:cNvPr id="21" name="TextBox 20"/>
+          <p:cNvSpPr txBox="1"/>
+          <p:nvPr/>
+        </p:nvSpPr>
+        <p:spPr>
+          <a:xfrm>
+            <a:off x="6309360" y="3017520"/>
+            <a:ext cx="5212080" cy="512064"/>
+          </a:xfrm>
+          <a:prstGeom prst="rect">
+            <a:avLst/>
+          </a:prstGeom>
+          <a:noFill/>
+        </p:spPr>
+        <p:txBody>
+          <a:bodyPr wrap="square" anchor="ctr">
+            <a:spAutoFit/>
+          </a:bodyPr>
+          <a:lstStyle/>
+          <a:p>
+            <a:pPr algn="l">
+              <a:spcBef>
+                <a:spcPts val="0"/>
+              </a:spcBef>
+              <a:spcAft>
+                <a:spcPts val="0"/>
+              </a:spcAft>
+            </a:pPr>
+            <a:r>
+              <a:rPr sz="1200" b="1">
+                <a:solidFill>
+                  <a:srgbClr val="16335C"/>
+                </a:solidFill>
+                <a:latin typeface="Calibri"/>
+              </a:rPr>
+              <a:t>Lower, predictable hosting cost</a:t>
+            </a:r>
+          </a:p>
+        </p:txBody>
+      </p:sp>
+      <p:sp>
+        <p:nvSpPr>
+          <p:cNvPr id="22" name="Rectangle 21"/>
+          <p:cNvSpPr/>
+          <p:nvPr/>
+        </p:nvSpPr>
+        <p:spPr>
+          <a:xfrm>
+            <a:off x="548640" y="3566160"/>
+            <a:ext cx="5486400" cy="512064"/>
+          </a:xfrm>
+          <a:prstGeom prst="rect">
+            <a:avLst/>
+          </a:prstGeom>
+          <a:solidFill>
+            <a:srgbClr val="F4F6F8"/>
+          </a:solidFill>
+          <a:ln>
+            <a:noFill/>
+          </a:ln>
+          <a:effectLst/>
+        </p:spPr>
+        <p:style>
+          <a:lnRef idx="1">
+            <a:schemeClr val="accent1"/>
+          </a:lnRef>
+          <a:fillRef idx="3">
+            <a:schemeClr val="accent1"/>
+          </a:fillRef>
+          <a:effectRef idx="2">
+            <a:schemeClr val="accent1"/>
+          </a:effectRef>
+          <a:fontRef idx="minor">
+            <a:schemeClr val="lt1"/>
+          </a:fontRef>
+        </p:style>
+        <p:txBody>
+          <a:bodyPr rtlCol="0" anchor="ctr"/>
+          <a:lstStyle/>
+          <a:p>
+            <a:pPr algn="ctr"/>
+          </a:p>
+        </p:txBody>
+      </p:sp>
+      <p:sp>
+        <p:nvSpPr>
+          <p:cNvPr id="23" name="Rectangle 22"/>
+          <p:cNvSpPr/>
+          <p:nvPr/>
+        </p:nvSpPr>
+        <p:spPr>
+          <a:xfrm>
+            <a:off x="6126480" y="3566160"/>
+            <a:ext cx="5486400" cy="512064"/>
+          </a:xfrm>
+          <a:prstGeom prst="rect">
+            <a:avLst/>
+          </a:prstGeom>
+          <a:solidFill>
+            <a:srgbClr val="F4F6F8"/>
+          </a:solidFill>
+          <a:ln>
+            <a:noFill/>
+          </a:ln>
+          <a:effectLst/>
+        </p:spPr>
+        <p:style>
+          <a:lnRef idx="1">
+            <a:schemeClr val="accent1"/>
+          </a:lnRef>
+          <a:fillRef idx="3">
+            <a:schemeClr val="accent1"/>
+          </a:fillRef>
+          <a:effectRef idx="2">
+            <a:schemeClr val="accent1"/>
+          </a:effectRef>
+          <a:fontRef idx="minor">
+            <a:schemeClr val="lt1"/>
+          </a:fontRef>
+        </p:style>
+        <p:txBody>
+          <a:bodyPr rtlCol="0" anchor="ctr"/>
+          <a:lstStyle/>
+          <a:p>
+            <a:pPr algn="ctr"/>
+          </a:p>
+        </p:txBody>
+      </p:sp>
+      <p:sp>
+        <p:nvSpPr>
+          <p:cNvPr id="24" name="TextBox 23"/>
+          <p:cNvSpPr txBox="1"/>
+          <p:nvPr/>
+        </p:nvSpPr>
+        <p:spPr>
+          <a:xfrm>
+            <a:off x="731520" y="3566160"/>
+            <a:ext cx="5212080" cy="512064"/>
+          </a:xfrm>
+          <a:prstGeom prst="rect">
+            <a:avLst/>
+          </a:prstGeom>
+          <a:noFill/>
+        </p:spPr>
+        <p:txBody>
+          <a:bodyPr wrap="square" anchor="ctr">
+            <a:spAutoFit/>
+          </a:bodyPr>
+          <a:lstStyle/>
+          <a:p>
+            <a:pPr algn="l">
+              <a:spcBef>
+                <a:spcPts val="0"/>
+              </a:spcBef>
+              <a:spcAft>
+                <a:spcPts val="0"/>
+              </a:spcAft>
+            </a:pPr>
+            <a:r>
+              <a:rPr sz="1200" b="0">
+                <a:solidFill>
+                  <a:srgbClr val="5B626D"/>
+                </a:solidFill>
+                <a:latin typeface="Calibri"/>
+              </a:rPr>
+              <a:t>Changes needed a developer</a:t>
+            </a:r>
+          </a:p>
+        </p:txBody>
+      </p:sp>
+      <p:sp>
+        <p:nvSpPr>
+          <p:cNvPr id="25" name="TextBox 24"/>
+          <p:cNvSpPr txBox="1"/>
+          <p:nvPr/>
+        </p:nvSpPr>
+        <p:spPr>
+          <a:xfrm>
+            <a:off x="6309360" y="3566160"/>
+            <a:ext cx="5212080" cy="512064"/>
+          </a:xfrm>
+          <a:prstGeom prst="rect">
+            <a:avLst/>
+          </a:prstGeom>
+          <a:noFill/>
+        </p:spPr>
+        <p:txBody>
+          <a:bodyPr wrap="square" anchor="ctr">
+            <a:spAutoFit/>
+          </a:bodyPr>
+          <a:lstStyle/>
+          <a:p>
+            <a:pPr algn="l">
+              <a:spcBef>
+                <a:spcPts val="0"/>
+              </a:spcBef>
+              <a:spcAft>
+                <a:spcPts val="0"/>
+              </a:spcAft>
+            </a:pPr>
+            <a:r>
+              <a:rPr sz="1200" b="1">
+                <a:solidFill>
+                  <a:srgbClr val="16335C"/>
+                </a:solidFill>
+                <a:latin typeface="Calibri"/>
+              </a:rPr>
+              <a:t>Team edits products &amp; pages themselves</a:t>
+            </a:r>
+          </a:p>
+        </p:txBody>
+      </p:sp>
+      <p:sp>
+        <p:nvSpPr>
+          <p:cNvPr id="26" name="Rectangle 25"/>
+          <p:cNvSpPr/>
+          <p:nvPr/>
+        </p:nvSpPr>
+        <p:spPr>
+          <a:xfrm>
+            <a:off x="548640" y="4114800"/>
+            <a:ext cx="5486400" cy="512064"/>
+          </a:xfrm>
+          <a:prstGeom prst="rect">
+            <a:avLst/>
+          </a:prstGeom>
+          <a:solidFill>
+            <a:srgbClr val="FFFFFF"/>
+          </a:solidFill>
+          <a:ln>
+            <a:noFill/>
+          </a:ln>
+          <a:effectLst/>
+        </p:spPr>
+        <p:style>
+          <a:lnRef idx="1">
+            <a:schemeClr val="accent1"/>
+          </a:lnRef>
+          <a:fillRef idx="3">
+            <a:schemeClr val="accent1"/>
+          </a:fillRef>
+          <a:effectRef idx="2">
+            <a:schemeClr val="accent1"/>
+          </a:effectRef>
+          <a:fontRef idx="minor">
+            <a:schemeClr val="lt1"/>
+          </a:fontRef>
+        </p:style>
+        <p:txBody>
+          <a:bodyPr rtlCol="0" anchor="ctr"/>
+          <a:lstStyle/>
+          <a:p>
+            <a:pPr algn="ctr"/>
+          </a:p>
+        </p:txBody>
+      </p:sp>
+      <p:sp>
+        <p:nvSpPr>
+          <p:cNvPr id="27" name="Rectangle 26"/>
+          <p:cNvSpPr/>
+          <p:nvPr/>
+        </p:nvSpPr>
+        <p:spPr>
+          <a:xfrm>
+            <a:off x="6126480" y="4114800"/>
+            <a:ext cx="5486400" cy="512064"/>
+          </a:xfrm>
+          <a:prstGeom prst="rect">
+            <a:avLst/>
+          </a:prstGeom>
+          <a:solidFill>
+            <a:srgbClr val="FFFFFF"/>
+          </a:solidFill>
+          <a:ln>
+            <a:noFill/>
+          </a:ln>
+          <a:effectLst/>
+        </p:spPr>
+        <p:style>
+          <a:lnRef idx="1">
+            <a:schemeClr val="accent1"/>
+          </a:lnRef>
+          <a:fillRef idx="3">
+            <a:schemeClr val="accent1"/>
+          </a:fillRef>
+          <a:effectRef idx="2">
+            <a:schemeClr val="accent1"/>
+          </a:effectRef>
+          <a:fontRef idx="minor">
+            <a:schemeClr val="lt1"/>
+          </a:fontRef>
+        </p:style>
+        <p:txBody>
+          <a:bodyPr rtlCol="0" anchor="ctr"/>
+          <a:lstStyle/>
+          <a:p>
+            <a:pPr algn="ctr"/>
+          </a:p>
+        </p:txBody>
+      </p:sp>
+      <p:sp>
+        <p:nvSpPr>
+          <p:cNvPr id="28" name="TextBox 27"/>
+          <p:cNvSpPr txBox="1"/>
+          <p:nvPr/>
+        </p:nvSpPr>
+        <p:spPr>
+          <a:xfrm>
+            <a:off x="731520" y="4114800"/>
+            <a:ext cx="5212080" cy="512064"/>
+          </a:xfrm>
+          <a:prstGeom prst="rect">
+            <a:avLst/>
+          </a:prstGeom>
+          <a:noFill/>
+        </p:spPr>
+        <p:txBody>
+          <a:bodyPr wrap="square" anchor="ctr">
+            <a:spAutoFit/>
+          </a:bodyPr>
+          <a:lstStyle/>
+          <a:p>
+            <a:pPr algn="l">
+              <a:spcBef>
+                <a:spcPts val="0"/>
+              </a:spcBef>
+              <a:spcAft>
+                <a:spcPts val="0"/>
+              </a:spcAft>
+            </a:pPr>
+            <a:r>
+              <a:rPr sz="1200" b="0">
+                <a:solidFill>
+                  <a:srgbClr val="5B626D"/>
+                </a:solidFill>
+                <a:latin typeface="Calibri"/>
+              </a:rPr>
+              <a:t>A brochure</a:t>
+            </a:r>
+          </a:p>
+        </p:txBody>
+      </p:sp>
+      <p:sp>
+        <p:nvSpPr>
+          <p:cNvPr id="29" name="TextBox 28"/>
+          <p:cNvSpPr txBox="1"/>
+          <p:nvPr/>
+        </p:nvSpPr>
+        <p:spPr>
+          <a:xfrm>
+            <a:off x="6309360" y="4114800"/>
+            <a:ext cx="5212080" cy="512064"/>
+          </a:xfrm>
+          <a:prstGeom prst="rect">
+            <a:avLst/>
+          </a:prstGeom>
+          <a:noFill/>
+        </p:spPr>
+        <p:txBody>
+          <a:bodyPr wrap="square" anchor="ctr">
+            <a:spAutoFit/>
+          </a:bodyPr>
+          <a:lstStyle/>
+          <a:p>
+            <a:pPr algn="l">
+              <a:spcBef>
+                <a:spcPts val="0"/>
+              </a:spcBef>
+              <a:spcAft>
+                <a:spcPts val="0"/>
+              </a:spcAft>
+            </a:pPr>
+            <a:r>
+              <a:rPr sz="1200" b="1">
+                <a:solidFill>
+                  <a:srgbClr val="16335C"/>
+                </a:solidFill>
+                <a:latin typeface="Calibri"/>
+              </a:rPr>
+              <a:t>Captures leads + builds its own SEO</a:t>
+            </a:r>
+          </a:p>
+        </p:txBody>
+      </p:sp>
+      <p:sp>
+        <p:nvSpPr>
+          <p:cNvPr id="30" name="Rectangle 29"/>
+          <p:cNvSpPr/>
+          <p:nvPr/>
+        </p:nvSpPr>
+        <p:spPr>
+          <a:xfrm>
+            <a:off x="548640" y="4663440"/>
+            <a:ext cx="5486400" cy="512064"/>
+          </a:xfrm>
+          <a:prstGeom prst="rect">
+            <a:avLst/>
+          </a:prstGeom>
+          <a:solidFill>
+            <a:srgbClr val="F4F6F8"/>
+          </a:solidFill>
+          <a:ln>
+            <a:noFill/>
+          </a:ln>
+          <a:effectLst/>
+        </p:spPr>
+        <p:style>
+          <a:lnRef idx="1">
+            <a:schemeClr val="accent1"/>
+          </a:lnRef>
+          <a:fillRef idx="3">
+            <a:schemeClr val="accent1"/>
+          </a:fillRef>
+          <a:effectRef idx="2">
+            <a:schemeClr val="accent1"/>
+          </a:effectRef>
+          <a:fontRef idx="minor">
+            <a:schemeClr val="lt1"/>
+          </a:fontRef>
+        </p:style>
+        <p:txBody>
+          <a:bodyPr rtlCol="0" anchor="ctr"/>
+          <a:lstStyle/>
+          <a:p>
+            <a:pPr algn="ctr"/>
+          </a:p>
+        </p:txBody>
+      </p:sp>
+      <p:sp>
+        <p:nvSpPr>
+          <p:cNvPr id="31" name="Rectangle 30"/>
+          <p:cNvSpPr/>
+          <p:nvPr/>
+        </p:nvSpPr>
+        <p:spPr>
+          <a:xfrm>
+            <a:off x="6126480" y="4663440"/>
+            <a:ext cx="5486400" cy="512064"/>
+          </a:xfrm>
+          <a:prstGeom prst="rect">
+            <a:avLst/>
+          </a:prstGeom>
+          <a:solidFill>
+            <a:srgbClr val="F4F6F8"/>
+          </a:solidFill>
+          <a:ln>
+            <a:noFill/>
+          </a:ln>
+          <a:effectLst/>
+        </p:spPr>
+        <p:style>
+          <a:lnRef idx="1">
+            <a:schemeClr val="accent1"/>
+          </a:lnRef>
+          <a:fillRef idx="3">
+            <a:schemeClr val="accent1"/>
+          </a:fillRef>
+          <a:effectRef idx="2">
+            <a:schemeClr val="accent1"/>
+          </a:effectRef>
+          <a:fontRef idx="minor">
+            <a:schemeClr val="lt1"/>
+          </a:fontRef>
+        </p:style>
+        <p:txBody>
+          <a:bodyPr rtlCol="0" anchor="ctr"/>
+          <a:lstStyle/>
+          <a:p>
+            <a:pPr algn="ctr"/>
+          </a:p>
+        </p:txBody>
+      </p:sp>
+      <p:sp>
+        <p:nvSpPr>
+          <p:cNvPr id="32" name="TextBox 31"/>
+          <p:cNvSpPr txBox="1"/>
+          <p:nvPr/>
+        </p:nvSpPr>
+        <p:spPr>
+          <a:xfrm>
+            <a:off x="731520" y="4663440"/>
+            <a:ext cx="5212080" cy="512064"/>
+          </a:xfrm>
+          <a:prstGeom prst="rect">
+            <a:avLst/>
+          </a:prstGeom>
+          <a:noFill/>
+        </p:spPr>
+        <p:txBody>
+          <a:bodyPr wrap="square" anchor="ctr">
+            <a:spAutoFit/>
+          </a:bodyPr>
+          <a:lstStyle/>
+          <a:p>
+            <a:pPr algn="l">
+              <a:spcBef>
+                <a:spcPts val="0"/>
+              </a:spcBef>
+              <a:spcAft>
+                <a:spcPts val="0"/>
+              </a:spcAft>
+            </a:pPr>
+            <a:r>
+              <a:rPr sz="1200" b="0">
+                <a:solidFill>
+                  <a:srgbClr val="5B626D"/>
+                </a:solidFill>
+                <a:latin typeface="Calibri"/>
+              </a:rPr>
+              <a:t>No BIM / specifier capture</a:t>
+            </a:r>
+          </a:p>
+        </p:txBody>
+      </p:sp>
+      <p:sp>
+        <p:nvSpPr>
+          <p:cNvPr id="33" name="TextBox 32"/>
+          <p:cNvSpPr txBox="1"/>
+          <p:nvPr/>
+        </p:nvSpPr>
+        <p:spPr>
+          <a:xfrm>
+            <a:off x="6309360" y="4663440"/>
+            <a:ext cx="5212080" cy="512064"/>
+          </a:xfrm>
+          <a:prstGeom prst="rect">
+            <a:avLst/>
+          </a:prstGeom>
+          <a:noFill/>
+        </p:spPr>
+        <p:txBody>
+          <a:bodyPr wrap="square" anchor="ctr">
+            <a:spAutoFit/>
+          </a:bodyPr>
+          <a:lstStyle/>
+          <a:p>
+            <a:pPr algn="l">
+              <a:spcBef>
+                <a:spcPts val="0"/>
+              </a:spcBef>
+              <a:spcAft>
+                <a:spcPts val="0"/>
+              </a:spcAft>
+            </a:pPr>
+            <a:r>
+              <a:rPr sz="1200" b="1">
+                <a:solidFill>
+                  <a:srgbClr val="16335C"/>
+                </a:solidFill>
+                <a:latin typeface="Calibri"/>
+              </a:rPr>
+              <a:t>"Download BIM file" sends marketing a warm lead</a:t>
+            </a:r>
+          </a:p>
+        </p:txBody>
+      </p:sp>
+      <p:sp>
+        <p:nvSpPr>
+          <p:cNvPr id="34" name="Rectangle 33"/>
+          <p:cNvSpPr/>
+          <p:nvPr/>
+        </p:nvSpPr>
+        <p:spPr>
+          <a:xfrm>
+            <a:off x="548640" y="5212080"/>
+            <a:ext cx="5486400" cy="512064"/>
+          </a:xfrm>
+          <a:prstGeom prst="rect">
+            <a:avLst/>
+          </a:prstGeom>
+          <a:solidFill>
+            <a:srgbClr val="FFFFFF"/>
+          </a:solidFill>
+          <a:ln>
+            <a:noFill/>
+          </a:ln>
+          <a:effectLst/>
+        </p:spPr>
+        <p:style>
+          <a:lnRef idx="1">
+            <a:schemeClr val="accent1"/>
+          </a:lnRef>
+          <a:fillRef idx="3">
+            <a:schemeClr val="accent1"/>
+          </a:fillRef>
+          <a:effectRef idx="2">
+            <a:schemeClr val="accent1"/>
+          </a:effectRef>
+          <a:fontRef idx="minor">
+            <a:schemeClr val="lt1"/>
+          </a:fontRef>
+        </p:style>
+        <p:txBody>
+          <a:bodyPr rtlCol="0" anchor="ctr"/>
+          <a:lstStyle/>
+          <a:p>
+            <a:pPr algn="ctr"/>
+          </a:p>
+        </p:txBody>
+      </p:sp>
+      <p:sp>
+        <p:nvSpPr>
+          <p:cNvPr id="35" name="Rectangle 34"/>
+          <p:cNvSpPr/>
+          <p:nvPr/>
+        </p:nvSpPr>
+        <p:spPr>
+          <a:xfrm>
+            <a:off x="6126480" y="5212080"/>
+            <a:ext cx="5486400" cy="512064"/>
+          </a:xfrm>
+          <a:prstGeom prst="rect">
+            <a:avLst/>
+          </a:prstGeom>
+          <a:solidFill>
+            <a:srgbClr val="FFFFFF"/>
+          </a:solidFill>
+          <a:ln>
+            <a:noFill/>
+          </a:ln>
+          <a:effectLst/>
+        </p:spPr>
+        <p:style>
+          <a:lnRef idx="1">
+            <a:schemeClr val="accent1"/>
+          </a:lnRef>
+          <a:fillRef idx="3">
+            <a:schemeClr val="accent1"/>
+          </a:fillRef>
+          <a:effectRef idx="2">
+            <a:schemeClr val="accent1"/>
+          </a:effectRef>
+          <a:fontRef idx="minor">
+            <a:schemeClr val="lt1"/>
+          </a:fontRef>
+        </p:style>
+        <p:txBody>
+          <a:bodyPr rtlCol="0" anchor="ctr"/>
+          <a:lstStyle/>
+          <a:p>
+            <a:pPr algn="ctr"/>
+          </a:p>
+        </p:txBody>
+      </p:sp>
+      <p:sp>
+        <p:nvSpPr>
+          <p:cNvPr id="36" name="TextBox 35"/>
+          <p:cNvSpPr txBox="1"/>
+          <p:nvPr/>
+        </p:nvSpPr>
+        <p:spPr>
+          <a:xfrm>
+            <a:off x="731520" y="5212080"/>
+            <a:ext cx="5212080" cy="512064"/>
+          </a:xfrm>
+          <a:prstGeom prst="rect">
+            <a:avLst/>
+          </a:prstGeom>
+          <a:noFill/>
+        </p:spPr>
+        <p:txBody>
+          <a:bodyPr wrap="square" anchor="ctr">
+            <a:spAutoFit/>
+          </a:bodyPr>
+          <a:lstStyle/>
+          <a:p>
+            <a:pPr algn="l">
+              <a:spcBef>
+                <a:spcPts val="0"/>
+              </a:spcBef>
+              <a:spcAft>
+                <a:spcPts val="0"/>
+              </a:spcAft>
+            </a:pPr>
+            <a:r>
+              <a:rPr sz="1200" b="0">
+                <a:solidFill>
+                  <a:srgbClr val="5B626D"/>
+                </a:solidFill>
+                <a:latin typeface="Calibri"/>
+              </a:rPr>
+              <a:t>Bespoke quotes = lots of back-and-forth</a:t>
+            </a:r>
+          </a:p>
+        </p:txBody>
+      </p:sp>
+      <p:sp>
+        <p:nvSpPr>
+          <p:cNvPr id="37" name="TextBox 36"/>
+          <p:cNvSpPr txBox="1"/>
+          <p:nvPr/>
+        </p:nvSpPr>
+        <p:spPr>
+          <a:xfrm>
+            <a:off x="6309360" y="5212080"/>
+            <a:ext cx="5212080" cy="512064"/>
+          </a:xfrm>
+          <a:prstGeom prst="rect">
+            <a:avLst/>
+          </a:prstGeom>
+          <a:noFill/>
+        </p:spPr>
+        <p:txBody>
+          <a:bodyPr wrap="square" anchor="ctr">
+            <a:spAutoFit/>
+          </a:bodyPr>
+          <a:lstStyle/>
+          <a:p>
+            <a:pPr algn="l">
+              <a:spcBef>
+                <a:spcPts val="0"/>
+              </a:spcBef>
+              <a:spcAft>
+                <a:spcPts val="0"/>
+              </a:spcAft>
+            </a:pPr>
+            <a:r>
+              <a:rPr sz="1200" b="1">
+                <a:solidFill>
+                  <a:srgbClr val="16335C"/>
+                </a:solidFill>
+                <a:latin typeface="Calibri"/>
+              </a:rPr>
+              <a:t>Flow+ Designer = ready-to-quote scheme</a:t>
+            </a:r>
+          </a:p>
+        </p:txBody>
+      </p:sp>
+      <p:sp>
+        <p:nvSpPr>
+          <p:cNvPr id="38" name="Rectangle 37"/>
+          <p:cNvSpPr/>
+          <p:nvPr/>
+        </p:nvSpPr>
+        <p:spPr>
+          <a:xfrm>
+            <a:off x="548640" y="5760720"/>
+            <a:ext cx="5486400" cy="512064"/>
+          </a:xfrm>
+          <a:prstGeom prst="rect">
+            <a:avLst/>
+          </a:prstGeom>
+          <a:solidFill>
+            <a:srgbClr val="F4F6F8"/>
+          </a:solidFill>
+          <a:ln>
+            <a:noFill/>
+          </a:ln>
+          <a:effectLst/>
+        </p:spPr>
+        <p:style>
+          <a:lnRef idx="1">
+            <a:schemeClr val="accent1"/>
+          </a:lnRef>
+          <a:fillRef idx="3">
+            <a:schemeClr val="accent1"/>
+          </a:fillRef>
+          <a:effectRef idx="2">
+            <a:schemeClr val="accent1"/>
+          </a:effectRef>
+          <a:fontRef idx="minor">
+            <a:schemeClr val="lt1"/>
+          </a:fontRef>
+        </p:style>
+        <p:txBody>
+          <a:bodyPr rtlCol="0" anchor="ctr"/>
+          <a:lstStyle/>
+          <a:p>
+            <a:pPr algn="ctr"/>
+          </a:p>
+        </p:txBody>
+      </p:sp>
+      <p:sp>
+        <p:nvSpPr>
+          <p:cNvPr id="39" name="Rectangle 38"/>
+          <p:cNvSpPr/>
+          <p:nvPr/>
+        </p:nvSpPr>
+        <p:spPr>
+          <a:xfrm>
+            <a:off x="6126480" y="5760720"/>
+            <a:ext cx="5486400" cy="512064"/>
+          </a:xfrm>
+          <a:prstGeom prst="rect">
+            <a:avLst/>
+          </a:prstGeom>
+          <a:solidFill>
+            <a:srgbClr val="F4F6F8"/>
+          </a:solidFill>
+          <a:ln>
+            <a:noFill/>
+          </a:ln>
+          <a:effectLst/>
+        </p:spPr>
+        <p:style>
+          <a:lnRef idx="1">
+            <a:schemeClr val="accent1"/>
+          </a:lnRef>
+          <a:fillRef idx="3">
+            <a:schemeClr val="accent1"/>
+          </a:fillRef>
+          <a:effectRef idx="2">
+            <a:schemeClr val="accent1"/>
+          </a:effectRef>
+          <a:fontRef idx="minor">
+            <a:schemeClr val="lt1"/>
+          </a:fontRef>
+        </p:style>
+        <p:txBody>
+          <a:bodyPr rtlCol="0" anchor="ctr"/>
+          <a:lstStyle/>
+          <a:p>
+            <a:pPr algn="ctr"/>
+          </a:p>
+        </p:txBody>
+      </p:sp>
+      <p:sp>
+        <p:nvSpPr>
+          <p:cNvPr id="40" name="TextBox 39"/>
+          <p:cNvSpPr txBox="1"/>
+          <p:nvPr/>
+        </p:nvSpPr>
+        <p:spPr>
+          <a:xfrm>
+            <a:off x="731520" y="5760720"/>
+            <a:ext cx="5212080" cy="512064"/>
+          </a:xfrm>
+          <a:prstGeom prst="rect">
+            <a:avLst/>
+          </a:prstGeom>
+          <a:noFill/>
+        </p:spPr>
+        <p:txBody>
+          <a:bodyPr wrap="square" anchor="ctr">
+            <a:spAutoFit/>
+          </a:bodyPr>
+          <a:lstStyle/>
+          <a:p>
+            <a:pPr algn="l">
+              <a:spcBef>
+                <a:spcPts val="0"/>
+              </a:spcBef>
+              <a:spcAft>
+                <a:spcPts val="0"/>
+              </a:spcAft>
+            </a:pPr>
+            <a:r>
+              <a:rPr sz="1200" b="0">
+                <a:solidFill>
+                  <a:srgbClr val="5B626D"/>
+                </a:solidFill>
+                <a:latin typeface="Calibri"/>
+              </a:rPr>
+              <a:t>Slower, page-builder overhead</a:t>
+            </a:r>
+          </a:p>
+        </p:txBody>
+      </p:sp>
+      <p:sp>
+        <p:nvSpPr>
+          <p:cNvPr id="41" name="TextBox 40"/>
+          <p:cNvSpPr txBox="1"/>
+          <p:nvPr/>
+        </p:nvSpPr>
+        <p:spPr>
+          <a:xfrm>
+            <a:off x="6309360" y="5760720"/>
+            <a:ext cx="5212080" cy="512064"/>
+          </a:xfrm>
+          <a:prstGeom prst="rect">
+            <a:avLst/>
+          </a:prstGeom>
+          <a:noFill/>
+        </p:spPr>
+        <p:txBody>
+          <a:bodyPr wrap="square" anchor="ctr">
+            <a:spAutoFit/>
+          </a:bodyPr>
+          <a:lstStyle/>
+          <a:p>
+            <a:pPr algn="l">
+              <a:spcBef>
+                <a:spcPts val="0"/>
+              </a:spcBef>
+              <a:spcAft>
+                <a:spcPts val="0"/>
+              </a:spcAft>
+            </a:pPr>
+            <a:r>
+              <a:rPr sz="1200" b="1">
+                <a:solidFill>
+                  <a:srgbClr val="16335C"/>
+                </a:solidFill>
+                <a:latin typeface="Calibri"/>
+              </a:rPr>
+              <a:t>Fast, modern, search-friendly</a:t>
+            </a:r>
+          </a:p>
+        </p:txBody>
+      </p:sp>
+      <p:sp>
+        <p:nvSpPr>
+          <p:cNvPr id="42" name="TextBox 41"/>
+          <p:cNvSpPr txBox="1"/>
+          <p:nvPr/>
+        </p:nvSpPr>
+        <p:spPr>
+          <a:xfrm>
+            <a:off x="548640" y="6400800"/>
+            <a:ext cx="7315200" cy="365760"/>
+          </a:xfrm>
+          <a:prstGeom prst="rect">
+            <a:avLst/>
+          </a:prstGeom>
+          <a:noFill/>
+        </p:spPr>
+        <p:txBody>
+          <a:bodyPr wrap="square" anchor="t">
+            <a:spAutoFit/>
+          </a:bodyPr>
+          <a:lstStyle/>
+          <a:p>
+            <a:pPr algn="l">
+              <a:spcBef>
+                <a:spcPts val="0"/>
+              </a:spcBef>
+              <a:spcAft>
+                <a:spcPts val="0"/>
+              </a:spcAft>
+            </a:pPr>
+            <a:r>
+              <a:rPr sz="1000" b="0">
+                <a:solidFill>
+                  <a:srgbClr val="5B626D"/>
+                </a:solidFill>
+                <a:latin typeface="Calibri"/>
+              </a:rPr>
+              <a:t>Ricoman — the new website</a:t>
+            </a:r>
+          </a:p>
+        </p:txBody>
+      </p:sp>
+      <p:sp>
+        <p:nvSpPr>
+          <p:cNvPr id="43" name="TextBox 42"/>
+          <p:cNvSpPr txBox="1"/>
+          <p:nvPr/>
+        </p:nvSpPr>
+        <p:spPr>
+          <a:xfrm>
+            <a:off x="10789920" y="6400800"/>
+            <a:ext cx="914400" cy="365760"/>
+          </a:xfrm>
+          <a:prstGeom prst="rect">
+            <a:avLst/>
+          </a:prstGeom>
+          <a:noFill/>
+        </p:spPr>
+        <p:txBody>
+          <a:bodyPr wrap="square" anchor="t">
+            <a:spAutoFit/>
+          </a:bodyPr>
+          <a:lstStyle/>
+          <a:p>
+            <a:pPr algn="r">
+              <a:spcBef>
+                <a:spcPts val="0"/>
+              </a:spcBef>
+              <a:spcAft>
+                <a:spcPts val="0"/>
+              </a:spcAft>
+            </a:pPr>
+            <a:r>
+              <a:rPr sz="1000" b="1">
+                <a:solidFill>
+                  <a:srgbClr val="5B626D"/>
+                </a:solidFill>
+                <a:latin typeface="Calibri"/>
+              </a:rPr>
+              <a:t>13</a:t>
+            </a:r>
+          </a:p>
+        </p:txBody>
+      </p:sp>
+    </p:spTree>
+  </p:cSld>
+  <p:clrMapOvr>
+    <a:masterClrMapping/>
+  </p:clrMapOvr>
+</p:sld>
+</file>
+
+<file path=ppt/slides/slide14.xml><?xml version="1.0" encoding="utf-8"?>
 <p:sld xmlns:a="http://schemas.openxmlformats.org/drawingml/2006/main" xmlns:p="http://schemas.openxmlformats.org/presentationml/2006/main" xmlns:r="http://schemas.openxmlformats.org/officeDocument/2006/relationships">
   <p:cSld>
     <p:spTree>

</xml_diff>